<commit_message>
Add speaker notes to each slide; fix title typo (Warable -> Wearable)
</commit_message>
<xml_diff>
--- a/analysis/fingerprint/19_fingerprint/efp_meirhasson/Fingerprint_20260902.pptx
+++ b/analysis/fingerprint/19_fingerprint/efp_meirhasson/Fingerprint_20260902.pptx
@@ -5,29 +5,29 @@
     <p:sldMasterId id="2147483648" r:id="rId1"/>
   </p:sldMasterIdLst>
   <p:sldIdLst>
-    <p:sldId id="256" r:id="rId7"/>
-    <p:sldId id="257" r:id="rId8"/>
-    <p:sldId id="258" r:id="rId9"/>
-    <p:sldId id="259" r:id="rId10"/>
-    <p:sldId id="260" r:id="rId11"/>
-    <p:sldId id="261" r:id="rId12"/>
-    <p:sldId id="262" r:id="rId13"/>
-    <p:sldId id="263" r:id="rId14"/>
-    <p:sldId id="264" r:id="rId15"/>
-    <p:sldId id="265" r:id="rId16"/>
-    <p:sldId id="266" r:id="rId17"/>
-    <p:sldId id="267" r:id="rId18"/>
-    <p:sldId id="268" r:id="rId19"/>
-    <p:sldId id="269" r:id="rId20"/>
-    <p:sldId id="270" r:id="rId21"/>
-    <p:sldId id="271" r:id="rId22"/>
-    <p:sldId id="272" r:id="rId23"/>
-    <p:sldId id="273" r:id="rId24"/>
-    <p:sldId id="274" r:id="rId25"/>
-    <p:sldId id="275" r:id="rId26"/>
-    <p:sldId id="276" r:id="rId27"/>
+    <p:sldId id="256" r:id="rId2"/>
+    <p:sldId id="257" r:id="rId3"/>
+    <p:sldId id="258" r:id="rId4"/>
+    <p:sldId id="259" r:id="rId5"/>
+    <p:sldId id="260" r:id="rId6"/>
+    <p:sldId id="261" r:id="rId7"/>
+    <p:sldId id="262" r:id="rId8"/>
+    <p:sldId id="263" r:id="rId9"/>
+    <p:sldId id="264" r:id="rId10"/>
+    <p:sldId id="265" r:id="rId11"/>
+    <p:sldId id="266" r:id="rId12"/>
+    <p:sldId id="267" r:id="rId13"/>
+    <p:sldId id="268" r:id="rId14"/>
+    <p:sldId id="269" r:id="rId15"/>
+    <p:sldId id="270" r:id="rId16"/>
+    <p:sldId id="271" r:id="rId17"/>
+    <p:sldId id="272" r:id="rId18"/>
+    <p:sldId id="273" r:id="rId19"/>
+    <p:sldId id="274" r:id="rId20"/>
+    <p:sldId id="275" r:id="rId21"/>
+    <p:sldId id="276" r:id="rId22"/>
   </p:sldIdLst>
-  <p:sldSz cx="12191695" cy="6858000" type="screen4x3"/>
+  <p:sldSz cx="12192000" cy="6858000"/>
   <p:notesSz cx="6858000" cy="9144000"/>
   <p:defaultTextStyle>
     <a:defPPr>
@@ -124,7 +124,1843 @@
       </a:defRPr>
     </a:lvl9pPr>
   </p:defaultTextStyle>
+  <p:extLst>
+    <p:ext uri="{EFAFB233-063F-42B5-8137-9DF3F51BA10A}">
+      <p15:sldGuideLst xmlns:p15="http://schemas.microsoft.com/office/powerpoint/2012/main">
+        <p15:guide id="1" orient="horz" pos="2160">
+          <p15:clr>
+            <a:srgbClr val="A4A3A4"/>
+          </p15:clr>
+        </p15:guide>
+        <p15:guide id="2" pos="2880">
+          <p15:clr>
+            <a:srgbClr val="A4A3A4"/>
+          </p15:clr>
+        </p15:guide>
+      </p15:sldGuideLst>
+    </p:ext>
+  </p:extLst>
 </p:presentation>
+</file>
+
+<file path=ppt/notesMasters/notesMaster1.xml><?xml version="1.0" encoding="utf-8"?>
+<p:notesMaster xmlns:a="http://schemas.openxmlformats.org/drawingml/2006/main" xmlns:p="http://schemas.openxmlformats.org/presentationml/2006/main" xmlns:r="http://schemas.openxmlformats.org/officeDocument/2006/relationships">
+  <p:cSld>
+    <p:bg>
+      <p:bgRef idx="1001">
+        <a:schemeClr val="bg1"/>
+      </p:bgRef>
+    </p:bg>
+    <p:spTree>
+      <p:nvGrpSpPr>
+        <p:cNvPr id="1" name=""/>
+        <p:cNvGrpSpPr/>
+        <p:nvPr/>
+      </p:nvGrpSpPr>
+      <p:grpSpPr>
+        <a:xfrm>
+          <a:off x="0" y="0"/>
+          <a:ext cx="0" cy="0"/>
+          <a:chOff x="0" y="0"/>
+          <a:chExt cx="0" cy="0"/>
+        </a:xfrm>
+      </p:grpSpPr>
+      <p:sp>
+        <p:nvSpPr>
+          <p:cNvPr id="2" name="Header Placeholder 1"/>
+          <p:cNvSpPr>
+            <a:spLocks noGrp="1"/>
+          </p:cNvSpPr>
+          <p:nvPr>
+            <p:ph type="hdr" sz="quarter"/>
+          </p:nvPr>
+        </p:nvSpPr>
+        <p:spPr>
+          <a:xfrm>
+            <a:off x="0" y="0"/>
+            <a:ext cx="2971800" cy="457200"/>
+          </a:xfrm>
+          <a:prstGeom prst="rect">
+            <a:avLst/>
+          </a:prstGeom>
+        </p:spPr>
+        <p:txBody>
+          <a:bodyPr vert="horz" lIns="91440" tIns="45720" rIns="91440" bIns="45720" rtlCol="0"/>
+          <a:lstStyle>
+            <a:lvl1pPr algn="l">
+              <a:defRPr sz="1200"/>
+            </a:lvl1pPr>
+          </a:lstStyle>
+          <a:p>
+            <a:endParaRPr lang="en-US"/>
+          </a:p>
+        </p:txBody>
+      </p:sp>
+      <p:sp>
+        <p:nvSpPr>
+          <p:cNvPr id="3" name="Date Placeholder 2"/>
+          <p:cNvSpPr>
+            <a:spLocks noGrp="1"/>
+          </p:cNvSpPr>
+          <p:nvPr>
+            <p:ph type="dt" idx="1"/>
+          </p:nvPr>
+        </p:nvSpPr>
+        <p:spPr>
+          <a:xfrm>
+            <a:off x="3884613" y="0"/>
+            <a:ext cx="2971800" cy="457200"/>
+          </a:xfrm>
+          <a:prstGeom prst="rect">
+            <a:avLst/>
+          </a:prstGeom>
+        </p:spPr>
+        <p:txBody>
+          <a:bodyPr vert="horz" lIns="91440" tIns="45720" rIns="91440" bIns="45720" rtlCol="0"/>
+          <a:lstStyle>
+            <a:lvl1pPr algn="r">
+              <a:defRPr sz="1200"/>
+            </a:lvl1pPr>
+          </a:lstStyle>
+          <a:p>
+            <a:fld id="{0F89C1C7-3DCD-1040-A9CF-14679D8B5DDD}" type="datetimeFigureOut">
+              <a:rPr lang="en-US" smtClean="0"/>
+              <a:t>10/17/16</a:t>
+            </a:fld>
+            <a:endParaRPr lang="en-US"/>
+          </a:p>
+        </p:txBody>
+      </p:sp>
+      <p:sp>
+        <p:nvSpPr>
+          <p:cNvPr id="4" name="Slide Image Placeholder 3"/>
+          <p:cNvSpPr>
+            <a:spLocks noGrp="1" noRot="1" noChangeAspect="1"/>
+          </p:cNvSpPr>
+          <p:nvPr>
+            <p:ph type="sldImg" idx="2"/>
+          </p:nvPr>
+        </p:nvSpPr>
+        <p:spPr>
+          <a:xfrm>
+            <a:off x="1143000" y="685800"/>
+            <a:ext cx="4572000" cy="3429000"/>
+          </a:xfrm>
+          <a:prstGeom prst="rect">
+            <a:avLst/>
+          </a:prstGeom>
+          <a:noFill/>
+          <a:ln w="12700">
+            <a:solidFill>
+              <a:prstClr val="black"/>
+            </a:solidFill>
+          </a:ln>
+        </p:spPr>
+        <p:txBody>
+          <a:bodyPr vert="horz" lIns="91440" tIns="45720" rIns="91440" bIns="45720" rtlCol="0" anchor="ctr"/>
+          <a:lstStyle/>
+          <a:p>
+            <a:endParaRPr lang="en-US"/>
+          </a:p>
+        </p:txBody>
+      </p:sp>
+      <p:sp>
+        <p:nvSpPr>
+          <p:cNvPr id="5" name="Notes Placeholder 4"/>
+          <p:cNvSpPr>
+            <a:spLocks noGrp="1"/>
+          </p:cNvSpPr>
+          <p:nvPr>
+            <p:ph type="body" sz="quarter" idx="3"/>
+          </p:nvPr>
+        </p:nvSpPr>
+        <p:spPr>
+          <a:xfrm>
+            <a:off x="685800" y="4343400"/>
+            <a:ext cx="5486400" cy="4114800"/>
+          </a:xfrm>
+          <a:prstGeom prst="rect">
+            <a:avLst/>
+          </a:prstGeom>
+        </p:spPr>
+        <p:txBody>
+          <a:bodyPr vert="horz" lIns="91440" tIns="45720" rIns="91440" bIns="45720" rtlCol="0"/>
+          <a:lstStyle/>
+          <a:p>
+            <a:pPr lvl="0"/>
+            <a:r>
+              <a:rPr lang="en-US" smtClean="0"/>
+              <a:t>Click to edit Master text styles</a:t>
+            </a:r>
+          </a:p>
+          <a:p>
+            <a:pPr lvl="1"/>
+            <a:r>
+              <a:rPr lang="en-US" smtClean="0"/>
+              <a:t>Second level</a:t>
+            </a:r>
+          </a:p>
+          <a:p>
+            <a:pPr lvl="2"/>
+            <a:r>
+              <a:rPr lang="en-US" smtClean="0"/>
+              <a:t>Third level</a:t>
+            </a:r>
+          </a:p>
+          <a:p>
+            <a:pPr lvl="3"/>
+            <a:r>
+              <a:rPr lang="en-US" smtClean="0"/>
+              <a:t>Fourth level</a:t>
+            </a:r>
+          </a:p>
+          <a:p>
+            <a:pPr lvl="4"/>
+            <a:r>
+              <a:rPr lang="en-US" smtClean="0"/>
+              <a:t>Fifth level</a:t>
+            </a:r>
+            <a:endParaRPr lang="en-US"/>
+          </a:p>
+        </p:txBody>
+      </p:sp>
+      <p:sp>
+        <p:nvSpPr>
+          <p:cNvPr id="6" name="Footer Placeholder 5"/>
+          <p:cNvSpPr>
+            <a:spLocks noGrp="1"/>
+          </p:cNvSpPr>
+          <p:nvPr>
+            <p:ph type="ftr" sz="quarter" idx="4"/>
+          </p:nvPr>
+        </p:nvSpPr>
+        <p:spPr>
+          <a:xfrm>
+            <a:off x="0" y="8685213"/>
+            <a:ext cx="2971800" cy="457200"/>
+          </a:xfrm>
+          <a:prstGeom prst="rect">
+            <a:avLst/>
+          </a:prstGeom>
+        </p:spPr>
+        <p:txBody>
+          <a:bodyPr vert="horz" lIns="91440" tIns="45720" rIns="91440" bIns="45720" rtlCol="0" anchor="b"/>
+          <a:lstStyle>
+            <a:lvl1pPr algn="l">
+              <a:defRPr sz="1200"/>
+            </a:lvl1pPr>
+          </a:lstStyle>
+          <a:p>
+            <a:endParaRPr lang="en-US"/>
+          </a:p>
+        </p:txBody>
+      </p:sp>
+      <p:sp>
+        <p:nvSpPr>
+          <p:cNvPr id="7" name="Slide Number Placeholder 6"/>
+          <p:cNvSpPr>
+            <a:spLocks noGrp="1"/>
+          </p:cNvSpPr>
+          <p:nvPr>
+            <p:ph type="sldNum" sz="quarter" idx="5"/>
+          </p:nvPr>
+        </p:nvSpPr>
+        <p:spPr>
+          <a:xfrm>
+            <a:off x="3884613" y="8685213"/>
+            <a:ext cx="2971800" cy="457200"/>
+          </a:xfrm>
+          <a:prstGeom prst="rect">
+            <a:avLst/>
+          </a:prstGeom>
+        </p:spPr>
+        <p:txBody>
+          <a:bodyPr vert="horz" lIns="91440" tIns="45720" rIns="91440" bIns="45720" rtlCol="0" anchor="b"/>
+          <a:lstStyle>
+            <a:lvl1pPr algn="r">
+              <a:defRPr sz="1200"/>
+            </a:lvl1pPr>
+          </a:lstStyle>
+          <a:p>
+            <a:fld id="{BB5E49A5-4136-284D-997B-48E1D791AD67}" type="slidenum">
+              <a:rPr lang="en-US" smtClean="0"/>
+              <a:t>‹#›</a:t>
+            </a:fld>
+            <a:endParaRPr lang="en-US"/>
+          </a:p>
+        </p:txBody>
+      </p:sp>
+    </p:spTree>
+    <p:extLst>
+      <p:ext uri="{BB962C8B-B14F-4D97-AF65-F5344CB8AC3E}">
+        <p14:creationId xmlns:p14="http://schemas.microsoft.com/office/powerpoint/2010/main" val="2623252185"/>
+      </p:ext>
+    </p:extLst>
+  </p:cSld>
+  <p:clrMap bg1="lt1" tx1="dk1" bg2="lt2" tx2="dk2" accent1="accent1" accent2="accent2" accent3="accent3" accent4="accent4" accent5="accent5" accent6="accent6" hlink="hlink" folHlink="folHlink"/>
+  <p:notesStyle>
+    <a:lvl1pPr marL="0" algn="l" defTabSz="457200" rtl="0" eaLnBrk="1" latinLnBrk="0" hangingPunct="1">
+      <a:defRPr sz="1200" kern="1200">
+        <a:solidFill>
+          <a:schemeClr val="tx1"/>
+        </a:solidFill>
+        <a:latin typeface="+mn-lt"/>
+        <a:ea typeface="+mn-ea"/>
+        <a:cs typeface="+mn-cs"/>
+      </a:defRPr>
+    </a:lvl1pPr>
+    <a:lvl2pPr marL="457200" algn="l" defTabSz="457200" rtl="0" eaLnBrk="1" latinLnBrk="0" hangingPunct="1">
+      <a:defRPr sz="1200" kern="1200">
+        <a:solidFill>
+          <a:schemeClr val="tx1"/>
+        </a:solidFill>
+        <a:latin typeface="+mn-lt"/>
+        <a:ea typeface="+mn-ea"/>
+        <a:cs typeface="+mn-cs"/>
+      </a:defRPr>
+    </a:lvl2pPr>
+    <a:lvl3pPr marL="914400" algn="l" defTabSz="457200" rtl="0" eaLnBrk="1" latinLnBrk="0" hangingPunct="1">
+      <a:defRPr sz="1200" kern="1200">
+        <a:solidFill>
+          <a:schemeClr val="tx1"/>
+        </a:solidFill>
+        <a:latin typeface="+mn-lt"/>
+        <a:ea typeface="+mn-ea"/>
+        <a:cs typeface="+mn-cs"/>
+      </a:defRPr>
+    </a:lvl3pPr>
+    <a:lvl4pPr marL="1371600" algn="l" defTabSz="457200" rtl="0" eaLnBrk="1" latinLnBrk="0" hangingPunct="1">
+      <a:defRPr sz="1200" kern="1200">
+        <a:solidFill>
+          <a:schemeClr val="tx1"/>
+        </a:solidFill>
+        <a:latin typeface="+mn-lt"/>
+        <a:ea typeface="+mn-ea"/>
+        <a:cs typeface="+mn-cs"/>
+      </a:defRPr>
+    </a:lvl4pPr>
+    <a:lvl5pPr marL="1828800" algn="l" defTabSz="457200" rtl="0" eaLnBrk="1" latinLnBrk="0" hangingPunct="1">
+      <a:defRPr sz="1200" kern="1200">
+        <a:solidFill>
+          <a:schemeClr val="tx1"/>
+        </a:solidFill>
+        <a:latin typeface="+mn-lt"/>
+        <a:ea typeface="+mn-ea"/>
+        <a:cs typeface="+mn-cs"/>
+      </a:defRPr>
+    </a:lvl5pPr>
+    <a:lvl6pPr marL="2286000" algn="l" defTabSz="457200" rtl="0" eaLnBrk="1" latinLnBrk="0" hangingPunct="1">
+      <a:defRPr sz="1200" kern="1200">
+        <a:solidFill>
+          <a:schemeClr val="tx1"/>
+        </a:solidFill>
+        <a:latin typeface="+mn-lt"/>
+        <a:ea typeface="+mn-ea"/>
+        <a:cs typeface="+mn-cs"/>
+      </a:defRPr>
+    </a:lvl6pPr>
+    <a:lvl7pPr marL="2743200" algn="l" defTabSz="457200" rtl="0" eaLnBrk="1" latinLnBrk="0" hangingPunct="1">
+      <a:defRPr sz="1200" kern="1200">
+        <a:solidFill>
+          <a:schemeClr val="tx1"/>
+        </a:solidFill>
+        <a:latin typeface="+mn-lt"/>
+        <a:ea typeface="+mn-ea"/>
+        <a:cs typeface="+mn-cs"/>
+      </a:defRPr>
+    </a:lvl7pPr>
+    <a:lvl8pPr marL="3200400" algn="l" defTabSz="457200" rtl="0" eaLnBrk="1" latinLnBrk="0" hangingPunct="1">
+      <a:defRPr sz="1200" kern="1200">
+        <a:solidFill>
+          <a:schemeClr val="tx1"/>
+        </a:solidFill>
+        <a:latin typeface="+mn-lt"/>
+        <a:ea typeface="+mn-ea"/>
+        <a:cs typeface="+mn-cs"/>
+      </a:defRPr>
+    </a:lvl8pPr>
+    <a:lvl9pPr marL="3657600" algn="l" defTabSz="457200" rtl="0" eaLnBrk="1" latinLnBrk="0" hangingPunct="1">
+      <a:defRPr sz="1200" kern="1200">
+        <a:solidFill>
+          <a:schemeClr val="tx1"/>
+        </a:solidFill>
+        <a:latin typeface="+mn-lt"/>
+        <a:ea typeface="+mn-ea"/>
+        <a:cs typeface="+mn-cs"/>
+      </a:defRPr>
+    </a:lvl9pPr>
+  </p:notesStyle>
+</p:notesMaster>
+</file>
+
+<file path=ppt/notesSlides/notesSlide1.xml><?xml version="1.0" encoding="utf-8"?>
+<p:notes xmlns:a="http://schemas.openxmlformats.org/drawingml/2006/main" xmlns:p="http://schemas.openxmlformats.org/presentationml/2006/main" xmlns:r="http://schemas.openxmlformats.org/officeDocument/2006/relationships">
+  <p:cSld>
+    <p:spTree>
+      <p:nvGrpSpPr>
+        <p:cNvPr id="1" name=""/>
+        <p:cNvGrpSpPr/>
+        <p:nvPr/>
+      </p:nvGrpSpPr>
+      <p:grpSpPr>
+        <a:xfrm>
+          <a:off x="0" y="0"/>
+          <a:ext cx="0" cy="0"/>
+          <a:chOff x="0" y="0"/>
+          <a:chExt cx="0" cy="0"/>
+        </a:xfrm>
+      </p:grpSpPr>
+      <p:sp>
+        <p:nvSpPr>
+          <p:cNvPr id="2" name="Slide Image Placeholder 1"/>
+          <p:cNvSpPr>
+            <a:spLocks noGrp="1"/>
+          </p:cNvSpPr>
+          <p:nvPr>
+            <p:ph type="sldImg" idx="2"/>
+          </p:nvPr>
+        </p:nvSpPr>
+        <p:spPr/>
+      </p:sp>
+      <p:sp>
+        <p:nvSpPr>
+          <p:cNvPr id="3" name="Notes Placeholder 2"/>
+          <p:cNvSpPr>
+            <a:spLocks noGrp="1"/>
+          </p:cNvSpPr>
+          <p:nvPr>
+            <p:ph type="body" idx="3" sz="quarter"/>
+          </p:nvPr>
+        </p:nvSpPr>
+        <p:spPr/>
+        <p:txBody>
+          <a:bodyPr/>
+          <a:lstStyle/>
+          <a:p>
+            <a:r>
+              <a:t>Title slide. Set the frame for the room: this talk moves from an experiential opening, through the science (replication + cross-cohort validation), to mindwear and a live demo. Fill in your name/lab/date on the slide itself before presenting.</a:t>
+            </a:r>
+          </a:p>
+        </p:txBody>
+      </p:sp>
+      <p:sp>
+        <p:nvSpPr>
+          <p:cNvPr id="4" name="Slide Number Placeholder 3"/>
+          <p:cNvSpPr>
+            <a:spLocks noGrp="1"/>
+          </p:cNvSpPr>
+          <p:nvPr>
+            <p:ph type="sldNum" idx="5" sz="quarter"/>
+          </p:nvPr>
+        </p:nvSpPr>
+        <p:spPr/>
+      </p:sp>
+    </p:spTree>
+  </p:cSld>
+  <p:clrMapOvr>
+    <a:masterClrMapping/>
+  </p:clrMapOvr>
+</p:notes>
+</file>
+
+<file path=ppt/notesSlides/notesSlide10.xml><?xml version="1.0" encoding="utf-8"?>
+<p:notes xmlns:a="http://schemas.openxmlformats.org/drawingml/2006/main" xmlns:p="http://schemas.openxmlformats.org/presentationml/2006/main" xmlns:r="http://schemas.openxmlformats.org/officeDocument/2006/relationships">
+  <p:cSld>
+    <p:spTree>
+      <p:nvGrpSpPr>
+        <p:cNvPr id="1" name=""/>
+        <p:cNvGrpSpPr/>
+        <p:nvPr/>
+      </p:nvGrpSpPr>
+      <p:grpSpPr>
+        <a:xfrm>
+          <a:off x="0" y="0"/>
+          <a:ext cx="0" cy="0"/>
+          <a:chOff x="0" y="0"/>
+          <a:chExt cx="0" cy="0"/>
+        </a:xfrm>
+      </p:grpSpPr>
+      <p:sp>
+        <p:nvSpPr>
+          <p:cNvPr id="2" name="Slide Image Placeholder 1"/>
+          <p:cNvSpPr>
+            <a:spLocks noGrp="1"/>
+          </p:cNvSpPr>
+          <p:nvPr>
+            <p:ph type="sldImg" idx="2"/>
+          </p:nvPr>
+        </p:nvSpPr>
+        <p:spPr/>
+      </p:sp>
+      <p:sp>
+        <p:nvSpPr>
+          <p:cNvPr id="3" name="Notes Placeholder 2"/>
+          <p:cNvSpPr>
+            <a:spLocks noGrp="1"/>
+          </p:cNvSpPr>
+          <p:nvPr>
+            <p:ph type="body" idx="3" sz="quarter"/>
+          </p:nvPr>
+        </p:nvSpPr>
+        <p:spPr/>
+        <p:txBody>
+          <a:bodyPr/>
+          <a:lstStyle/>
+          <a:p>
+            <a:r>
+              <a:t>Their results: visual cortex (n=4) -- EFP beat a traditional alpha-power predictor in ALL subjects, beat a fixed-delay predictor in all subjects (75% significantly). Amygdala (17/20 subjects cleared their validation threshold) -- EFP beat theta/alpha in 95% (significant), beat fixed-delay in 90% (35% significant); 85% of subjects reached r&gt;0.6. Best electrode for amygdala was P3; the dmPFC control region was best predicted by a DIFFERENT electrode (Fz) with a different frequency pattern -- evidence the fingerprint is region-specific, not a generic global signal. Delay varied by subject, electrode, AND frequency band -- direct justification for the sliding per-band delay design.</a:t>
+            </a:r>
+          </a:p>
+        </p:txBody>
+      </p:sp>
+      <p:sp>
+        <p:nvSpPr>
+          <p:cNvPr id="4" name="Slide Number Placeholder 3"/>
+          <p:cNvSpPr>
+            <a:spLocks noGrp="1"/>
+          </p:cNvSpPr>
+          <p:nvPr>
+            <p:ph type="sldNum" idx="5" sz="quarter"/>
+          </p:nvPr>
+        </p:nvSpPr>
+        <p:spPr/>
+      </p:sp>
+    </p:spTree>
+  </p:cSld>
+  <p:clrMapOvr>
+    <a:masterClrMapping/>
+  </p:clrMapOvr>
+</p:notes>
+</file>
+
+<file path=ppt/notesSlides/notesSlide11.xml><?xml version="1.0" encoding="utf-8"?>
+<p:notes xmlns:a="http://schemas.openxmlformats.org/drawingml/2006/main" xmlns:p="http://schemas.openxmlformats.org/presentationml/2006/main" xmlns:r="http://schemas.openxmlformats.org/officeDocument/2006/relationships">
+  <p:cSld>
+    <p:spTree>
+      <p:nvGrpSpPr>
+        <p:cNvPr id="1" name=""/>
+        <p:cNvGrpSpPr/>
+        <p:nvPr/>
+      </p:nvGrpSpPr>
+      <p:grpSpPr>
+        <a:xfrm>
+          <a:off x="0" y="0"/>
+          <a:ext cx="0" cy="0"/>
+          <a:chOff x="0" y="0"/>
+          <a:chExt cx="0" cy="0"/>
+        </a:xfrm>
+      </p:grpSpPr>
+      <p:sp>
+        <p:nvSpPr>
+          <p:cNvPr id="2" name="Slide Image Placeholder 1"/>
+          <p:cNvSpPr>
+            <a:spLocks noGrp="1"/>
+          </p:cNvSpPr>
+          <p:nvPr>
+            <p:ph type="sldImg" idx="2"/>
+          </p:nvPr>
+        </p:nvSpPr>
+        <p:spPr/>
+      </p:sp>
+      <p:sp>
+        <p:nvSpPr>
+          <p:cNvPr id="3" name="Notes Placeholder 2"/>
+          <p:cNvSpPr>
+            <a:spLocks noGrp="1"/>
+          </p:cNvSpPr>
+          <p:nvPr>
+            <p:ph type="body" idx="3" sz="quarter"/>
+          </p:nvPr>
+        </p:nvSpPr>
+        <p:spPr/>
+        <p:txBody>
+          <a:bodyPr/>
+          <a:lstStyle/>
+          <a:p>
+            <a:r>
+              <a:t>Explain in plain language (you'll get asked about this, know it cold): for each electrode, break the EEG into 10 frequency bands, look at how each band's power over the last ~12 seconds predicts the fMRI signal right now, and let a regression model learn a separate best lag PER frequency band -- no assumed fixed delay. Why this is legit: fit and evaluated with double cross-validation (outer loop holds out blocks of time, inner loop picks the regularization strength) -- the numbers on the next slides are not fit-and-report-the-same-data results.</a:t>
+            </a:r>
+          </a:p>
+        </p:txBody>
+      </p:sp>
+      <p:sp>
+        <p:nvSpPr>
+          <p:cNvPr id="4" name="Slide Number Placeholder 3"/>
+          <p:cNvSpPr>
+            <a:spLocks noGrp="1"/>
+          </p:cNvSpPr>
+          <p:nvPr>
+            <p:ph type="sldNum" idx="5" sz="quarter"/>
+          </p:nvPr>
+        </p:nvSpPr>
+        <p:spPr/>
+      </p:sp>
+    </p:spTree>
+  </p:cSld>
+  <p:clrMapOvr>
+    <a:masterClrMapping/>
+  </p:clrMapOvr>
+</p:notes>
+</file>
+
+<file path=ppt/notesSlides/notesSlide12.xml><?xml version="1.0" encoding="utf-8"?>
+<p:notes xmlns:a="http://schemas.openxmlformats.org/drawingml/2006/main" xmlns:p="http://schemas.openxmlformats.org/presentationml/2006/main" xmlns:r="http://schemas.openxmlformats.org/officeDocument/2006/relationships">
+  <p:cSld>
+    <p:spTree>
+      <p:nvGrpSpPr>
+        <p:cNvPr id="1" name=""/>
+        <p:cNvGrpSpPr/>
+        <p:nvPr/>
+      </p:nvGrpSpPr>
+      <p:grpSpPr>
+        <a:xfrm>
+          <a:off x="0" y="0"/>
+          <a:ext cx="0" cy="0"/>
+          <a:chOff x="0" y="0"/>
+          <a:chExt cx="0" cy="0"/>
+        </a:xfrm>
+      </p:grpSpPr>
+      <p:sp>
+        <p:nvSpPr>
+          <p:cNvPr id="2" name="Slide Image Placeholder 1"/>
+          <p:cNvSpPr>
+            <a:spLocks noGrp="1"/>
+          </p:cNvSpPr>
+          <p:nvPr>
+            <p:ph type="sldImg" idx="2"/>
+          </p:nvPr>
+        </p:nvSpPr>
+        <p:spPr/>
+      </p:sp>
+      <p:sp>
+        <p:nvSpPr>
+          <p:cNvPr id="3" name="Notes Placeholder 2"/>
+          <p:cNvSpPr>
+            <a:spLocks noGrp="1"/>
+          </p:cNvSpPr>
+          <p:nvPr>
+            <p:ph type="body" idx="3" sz="quarter"/>
+          </p:nvPr>
+        </p:nvSpPr>
+        <p:spPr/>
+        <p:txBody>
+          <a:bodyPr/>
+          <a:lstStyle/>
+          <a:p>
+            <a:r>
+              <a:t>n=19, each subject's own single best electrode. EFP beats both a fixed-HRF baseline and the traditional theta/alpha ratio across every target -- strongest for CEN, PDA, and their global-signal-controlled variants (r~0.14-0.18). Say these as correlations between predicted and actual signal, not accuracy percentages.</a:t>
+            </a:r>
+          </a:p>
+        </p:txBody>
+      </p:sp>
+      <p:sp>
+        <p:nvSpPr>
+          <p:cNvPr id="4" name="Slide Number Placeholder 3"/>
+          <p:cNvSpPr>
+            <a:spLocks noGrp="1"/>
+          </p:cNvSpPr>
+          <p:nvPr>
+            <p:ph type="sldNum" idx="5" sz="quarter"/>
+          </p:nvPr>
+        </p:nvSpPr>
+        <p:spPr/>
+      </p:sp>
+    </p:spTree>
+  </p:cSld>
+  <p:clrMapOvr>
+    <a:masterClrMapping/>
+  </p:clrMapOvr>
+</p:notes>
+</file>
+
+<file path=ppt/notesSlides/notesSlide13.xml><?xml version="1.0" encoding="utf-8"?>
+<p:notes xmlns:a="http://schemas.openxmlformats.org/drawingml/2006/main" xmlns:p="http://schemas.openxmlformats.org/presentationml/2006/main" xmlns:r="http://schemas.openxmlformats.org/officeDocument/2006/relationships">
+  <p:cSld>
+    <p:spTree>
+      <p:nvGrpSpPr>
+        <p:cNvPr id="1" name=""/>
+        <p:cNvGrpSpPr/>
+        <p:nvPr/>
+      </p:nvGrpSpPr>
+      <p:grpSpPr>
+        <a:xfrm>
+          <a:off x="0" y="0"/>
+          <a:ext cx="0" cy="0"/>
+          <a:chOff x="0" y="0"/>
+          <a:chExt cx="0" cy="0"/>
+        </a:xfrm>
+      </p:grpSpPr>
+      <p:sp>
+        <p:nvSpPr>
+          <p:cNvPr id="2" name="Slide Image Placeholder 1"/>
+          <p:cNvSpPr>
+            <a:spLocks noGrp="1"/>
+          </p:cNvSpPr>
+          <p:nvPr>
+            <p:ph type="sldImg" idx="2"/>
+          </p:nvPr>
+        </p:nvSpPr>
+        <p:spPr/>
+      </p:sp>
+      <p:sp>
+        <p:nvSpPr>
+          <p:cNvPr id="3" name="Notes Placeholder 2"/>
+          <p:cNvSpPr>
+            <a:spLocks noGrp="1"/>
+          </p:cNvSpPr>
+          <p:nvPr>
+            <p:ph type="body" idx="3" sz="quarter"/>
+          </p:nvPr>
+        </p:nvSpPr>
+        <p:spPr/>
+        <p:txBody>
+          <a:bodyPr/>
+          <a:lstStyle/>
+          <a:p>
+            <a:r>
+              <a:t>Leave-one-subject-out: train a single GENERAL model on 18 subjects, predict the 19th, who was never seen -- a harder, more honest test than the within-subject slide (there, each subject had their own fitted model). CEN r=+0.114 (p=.001), DMN r=+0.107 (p=.001), PDA r=+0.157 (p=.002). This is evidence the EFP captures a real, shared EEG-to-BOLD mapping, not subject-specific overfitting.</a:t>
+            </a:r>
+          </a:p>
+        </p:txBody>
+      </p:sp>
+      <p:sp>
+        <p:nvSpPr>
+          <p:cNvPr id="4" name="Slide Number Placeholder 3"/>
+          <p:cNvSpPr>
+            <a:spLocks noGrp="1"/>
+          </p:cNvSpPr>
+          <p:nvPr>
+            <p:ph type="sldNum" idx="5" sz="quarter"/>
+          </p:nvPr>
+        </p:nvSpPr>
+        <p:spPr/>
+      </p:sp>
+    </p:spTree>
+  </p:cSld>
+  <p:clrMapOvr>
+    <a:masterClrMapping/>
+  </p:clrMapOvr>
+</p:notes>
+</file>
+
+<file path=ppt/notesSlides/notesSlide14.xml><?xml version="1.0" encoding="utf-8"?>
+<p:notes xmlns:a="http://schemas.openxmlformats.org/drawingml/2006/main" xmlns:p="http://schemas.openxmlformats.org/presentationml/2006/main" xmlns:r="http://schemas.openxmlformats.org/officeDocument/2006/relationships">
+  <p:cSld>
+    <p:spTree>
+      <p:nvGrpSpPr>
+        <p:cNvPr id="1" name=""/>
+        <p:cNvGrpSpPr/>
+        <p:nvPr/>
+      </p:nvGrpSpPr>
+      <p:grpSpPr>
+        <a:xfrm>
+          <a:off x="0" y="0"/>
+          <a:ext cx="0" cy="0"/>
+          <a:chOff x="0" y="0"/>
+          <a:chExt cx="0" cy="0"/>
+        </a:xfrm>
+      </p:grpSpPr>
+      <p:sp>
+        <p:nvSpPr>
+          <p:cNvPr id="2" name="Slide Image Placeholder 1"/>
+          <p:cNvSpPr>
+            <a:spLocks noGrp="1"/>
+          </p:cNvSpPr>
+          <p:nvPr>
+            <p:ph type="sldImg" idx="2"/>
+          </p:nvPr>
+        </p:nvSpPr>
+        <p:spPr/>
+      </p:sp>
+      <p:sp>
+        <p:nvSpPr>
+          <p:cNvPr id="3" name="Notes Placeholder 2"/>
+          <p:cNvSpPr>
+            <a:spLocks noGrp="1"/>
+          </p:cNvSpPr>
+          <p:nvPr>
+            <p:ph type="body" idx="3" sz="quarter"/>
+          </p:nvPr>
+        </p:nvSpPr>
+        <p:spPr/>
+        <p:txBody>
+          <a:bodyPr/>
+          <a:lstStyle/>
+          <a:p>
+            <a:r>
+              <a:t>sub-dmnelf002/003 were recovered via R128 fMRI trigger-marker reconstruction, growing the cohort from 17 to 19. 3 targets moved from non-significant/marginal to clearly significant; several others got stronger; nothing regressed meaningfully. Useful if asked about sample size: the signal is getting cleaner as the cohort grows, not noisier.</a:t>
+            </a:r>
+          </a:p>
+        </p:txBody>
+      </p:sp>
+      <p:sp>
+        <p:nvSpPr>
+          <p:cNvPr id="4" name="Slide Number Placeholder 3"/>
+          <p:cNvSpPr>
+            <a:spLocks noGrp="1"/>
+          </p:cNvSpPr>
+          <p:nvPr>
+            <p:ph type="sldNum" idx="5" sz="quarter"/>
+          </p:nvPr>
+        </p:nvSpPr>
+        <p:spPr/>
+      </p:sp>
+    </p:spTree>
+  </p:cSld>
+  <p:clrMapOvr>
+    <a:masterClrMapping/>
+  </p:clrMapOvr>
+</p:notes>
+</file>
+
+<file path=ppt/notesSlides/notesSlide15.xml><?xml version="1.0" encoding="utf-8"?>
+<p:notes xmlns:a="http://schemas.openxmlformats.org/drawingml/2006/main" xmlns:p="http://schemas.openxmlformats.org/presentationml/2006/main" xmlns:r="http://schemas.openxmlformats.org/officeDocument/2006/relationships">
+  <p:cSld>
+    <p:spTree>
+      <p:nvGrpSpPr>
+        <p:cNvPr id="1" name=""/>
+        <p:cNvGrpSpPr/>
+        <p:nvPr/>
+      </p:nvGrpSpPr>
+      <p:grpSpPr>
+        <a:xfrm>
+          <a:off x="0" y="0"/>
+          <a:ext cx="0" cy="0"/>
+          <a:chOff x="0" y="0"/>
+          <a:chExt cx="0" cy="0"/>
+        </a:xfrm>
+      </p:grpSpPr>
+      <p:sp>
+        <p:nvSpPr>
+          <p:cNvPr id="2" name="Slide Image Placeholder 1"/>
+          <p:cNvSpPr>
+            <a:spLocks noGrp="1"/>
+          </p:cNvSpPr>
+          <p:nvPr>
+            <p:ph type="sldImg" idx="2"/>
+          </p:nvPr>
+        </p:nvSpPr>
+        <p:spPr/>
+      </p:sp>
+      <p:sp>
+        <p:nvSpPr>
+          <p:cNvPr id="3" name="Notes Placeholder 2"/>
+          <p:cNvSpPr>
+            <a:spLocks noGrp="1"/>
+          </p:cNvSpPr>
+          <p:nvPr>
+            <p:ph type="body" idx="3" sz="quarter"/>
+          </p:nvPr>
+        </p:nvSpPr>
+        <p:spPr/>
+        <p:txBody>
+          <a:bodyPr/>
+          <a:lstStyle/>
+          <a:p>
+            <a:r>
+              <a:t>THE HEADLINE SLIDE. The DMNELF-trained fingerprint, applied with ZERO retraining, to a completely different study's participants (rtBPD) -- CEN r=+0.165 (nf1, p&lt;.001) / +0.161 (nf2, p=.002); DMN r=+0.084 (nf1, p=.001) / +0.077 (nf2, p=.008). Two independent replications in a cohort the model never saw during training. This answers 'does this generalize beyond your own dataset' -- say so explicitly. Note (only if asked): PDA also replicates here (nf1 p=.017, nf2 p=.007) in this classic research-cap method -- but that is a SEPARATE finding from mindwear's deployed portable decoder, where PDA specifically has no out-of-sample validity. Don't conflate the two. The slide leads with CEN/DMN because those are the targets that transfer most consistently across every version of this analysis.</a:t>
+            </a:r>
+          </a:p>
+        </p:txBody>
+      </p:sp>
+      <p:sp>
+        <p:nvSpPr>
+          <p:cNvPr id="4" name="Slide Number Placeholder 3"/>
+          <p:cNvSpPr>
+            <a:spLocks noGrp="1"/>
+          </p:cNvSpPr>
+          <p:nvPr>
+            <p:ph type="sldNum" idx="5" sz="quarter"/>
+          </p:nvPr>
+        </p:nvSpPr>
+        <p:spPr/>
+      </p:sp>
+    </p:spTree>
+  </p:cSld>
+  <p:clrMapOvr>
+    <a:masterClrMapping/>
+  </p:clrMapOvr>
+</p:notes>
+</file>
+
+<file path=ppt/notesSlides/notesSlide16.xml><?xml version="1.0" encoding="utf-8"?>
+<p:notes xmlns:a="http://schemas.openxmlformats.org/drawingml/2006/main" xmlns:p="http://schemas.openxmlformats.org/presentationml/2006/main" xmlns:r="http://schemas.openxmlformats.org/officeDocument/2006/relationships">
+  <p:cSld>
+    <p:spTree>
+      <p:nvGrpSpPr>
+        <p:cNvPr id="1" name=""/>
+        <p:cNvGrpSpPr/>
+        <p:nvPr/>
+      </p:nvGrpSpPr>
+      <p:grpSpPr>
+        <a:xfrm>
+          <a:off x="0" y="0"/>
+          <a:ext cx="0" cy="0"/>
+          <a:chOff x="0" y="0"/>
+          <a:chExt cx="0" cy="0"/>
+        </a:xfrm>
+      </p:grpSpPr>
+      <p:sp>
+        <p:nvSpPr>
+          <p:cNvPr id="2" name="Slide Image Placeholder 1"/>
+          <p:cNvSpPr>
+            <a:spLocks noGrp="1"/>
+          </p:cNvSpPr>
+          <p:nvPr>
+            <p:ph type="sldImg" idx="2"/>
+          </p:nvPr>
+        </p:nvSpPr>
+        <p:spPr/>
+      </p:sp>
+      <p:sp>
+        <p:nvSpPr>
+          <p:cNvPr id="3" name="Notes Placeholder 2"/>
+          <p:cNvSpPr>
+            <a:spLocks noGrp="1"/>
+          </p:cNvSpPr>
+          <p:nvPr>
+            <p:ph type="body" idx="3" sz="quarter"/>
+          </p:nvPr>
+        </p:nvSpPr>
+        <p:spPr/>
+        <p:txBody>
+          <a:bodyPr/>
+          <a:lstStyle/>
+          <a:p>
+            <a:r>
+              <a:t>The model was never told anything about hemodynamics, yet the learned [frequency x delay] weights peak at physiologically plausible 4-7 second lags, differing across frequency bands. Good 'this learned something real, not noise' visual if anyone's skeptical about a black-box model.</a:t>
+            </a:r>
+          </a:p>
+        </p:txBody>
+      </p:sp>
+      <p:sp>
+        <p:nvSpPr>
+          <p:cNvPr id="4" name="Slide Number Placeholder 3"/>
+          <p:cNvSpPr>
+            <a:spLocks noGrp="1"/>
+          </p:cNvSpPr>
+          <p:nvPr>
+            <p:ph type="sldNum" idx="5" sz="quarter"/>
+          </p:nvPr>
+        </p:nvSpPr>
+        <p:spPr/>
+      </p:sp>
+    </p:spTree>
+  </p:cSld>
+  <p:clrMapOvr>
+    <a:masterClrMapping/>
+  </p:clrMapOvr>
+</p:notes>
+</file>
+
+<file path=ppt/notesSlides/notesSlide17.xml><?xml version="1.0" encoding="utf-8"?>
+<p:notes xmlns:a="http://schemas.openxmlformats.org/drawingml/2006/main" xmlns:p="http://schemas.openxmlformats.org/presentationml/2006/main" xmlns:r="http://schemas.openxmlformats.org/officeDocument/2006/relationships">
+  <p:cSld>
+    <p:spTree>
+      <p:nvGrpSpPr>
+        <p:cNvPr id="1" name=""/>
+        <p:cNvGrpSpPr/>
+        <p:nvPr/>
+      </p:nvGrpSpPr>
+      <p:grpSpPr>
+        <a:xfrm>
+          <a:off x="0" y="0"/>
+          <a:ext cx="0" cy="0"/>
+          <a:chOff x="0" y="0"/>
+          <a:chExt cx="0" cy="0"/>
+        </a:xfrm>
+      </p:grpSpPr>
+      <p:sp>
+        <p:nvSpPr>
+          <p:cNvPr id="2" name="Slide Image Placeholder 1"/>
+          <p:cNvSpPr>
+            <a:spLocks noGrp="1"/>
+          </p:cNvSpPr>
+          <p:nvPr>
+            <p:ph type="sldImg" idx="2"/>
+          </p:nvPr>
+        </p:nvSpPr>
+        <p:spPr/>
+      </p:sp>
+      <p:sp>
+        <p:nvSpPr>
+          <p:cNvPr id="3" name="Notes Placeholder 2"/>
+          <p:cNvSpPr>
+            <a:spLocks noGrp="1"/>
+          </p:cNvSpPr>
+          <p:nvPr>
+            <p:ph type="body" idx="3" sz="quarter"/>
+          </p:nvPr>
+        </p:nvSpPr>
+        <p:spPr/>
+        <p:txBody>
+          <a:bodyPr/>
+          <a:lstStyle/>
+          <a:p>
+            <a:r>
+              <a:t>Pivot from science to product: we now have a general, cross-cohort-validated EEG fingerprint for CEN and DMN -- enough signal to build something usable outside the scanner, not with a 31-channel research cap but a consumer-grade 12-channel portable headset. That tool is mindwear.</a:t>
+            </a:r>
+          </a:p>
+        </p:txBody>
+      </p:sp>
+      <p:sp>
+        <p:nvSpPr>
+          <p:cNvPr id="4" name="Slide Number Placeholder 3"/>
+          <p:cNvSpPr>
+            <a:spLocks noGrp="1"/>
+          </p:cNvSpPr>
+          <p:nvPr>
+            <p:ph type="sldNum" idx="5" sz="quarter"/>
+          </p:nvPr>
+        </p:nvSpPr>
+        <p:spPr/>
+      </p:sp>
+    </p:spTree>
+  </p:cSld>
+  <p:clrMapOvr>
+    <a:masterClrMapping/>
+  </p:clrMapOvr>
+</p:notes>
+</file>
+
+<file path=ppt/notesSlides/notesSlide18.xml><?xml version="1.0" encoding="utf-8"?>
+<p:notes xmlns:a="http://schemas.openxmlformats.org/drawingml/2006/main" xmlns:p="http://schemas.openxmlformats.org/presentationml/2006/main" xmlns:r="http://schemas.openxmlformats.org/officeDocument/2006/relationships">
+  <p:cSld>
+    <p:spTree>
+      <p:nvGrpSpPr>
+        <p:cNvPr id="1" name=""/>
+        <p:cNvGrpSpPr/>
+        <p:nvPr/>
+      </p:nvGrpSpPr>
+      <p:grpSpPr>
+        <a:xfrm>
+          <a:off x="0" y="0"/>
+          <a:ext cx="0" cy="0"/>
+          <a:chOff x="0" y="0"/>
+          <a:chExt cx="0" cy="0"/>
+        </a:xfrm>
+      </p:grpSpPr>
+      <p:sp>
+        <p:nvSpPr>
+          <p:cNvPr id="2" name="Slide Image Placeholder 1"/>
+          <p:cNvSpPr>
+            <a:spLocks noGrp="1"/>
+          </p:cNvSpPr>
+          <p:nvPr>
+            <p:ph type="sldImg" idx="2"/>
+          </p:nvPr>
+        </p:nvSpPr>
+        <p:spPr/>
+      </p:sp>
+      <p:sp>
+        <p:nvSpPr>
+          <p:cNvPr id="3" name="Notes Placeholder 2"/>
+          <p:cNvSpPr>
+            <a:spLocks noGrp="1"/>
+          </p:cNvSpPr>
+          <p:nvPr>
+            <p:ph type="body" idx="3" sz="quarter"/>
+          </p:nvPr>
+        </p:nvSpPr>
+        <p:spPr/>
+        <p:txBody>
+          <a:bodyPr/>
+          <a:lstStyle/>
+          <a:p>
+            <a:r>
+              <a:t>mindwear runs the identical visual ball-feedback paradigm, driven by the same EFP approach, montage-restricted to the portable headset's 12 channels. Built-in comparison mode: replay a recorded session and watch the EEG-decoded ball run side by side with the scanner ground truth, on the same run. Add a screenshot/architecture diagram here if you have one.</a:t>
+            </a:r>
+          </a:p>
+        </p:txBody>
+      </p:sp>
+      <p:sp>
+        <p:nvSpPr>
+          <p:cNvPr id="4" name="Slide Number Placeholder 3"/>
+          <p:cNvSpPr>
+            <a:spLocks noGrp="1"/>
+          </p:cNvSpPr>
+          <p:nvPr>
+            <p:ph type="sldNum" idx="5" sz="quarter"/>
+          </p:nvPr>
+        </p:nvSpPr>
+        <p:spPr/>
+      </p:sp>
+    </p:spTree>
+  </p:cSld>
+  <p:clrMapOvr>
+    <a:masterClrMapping/>
+  </p:clrMapOvr>
+</p:notes>
+</file>
+
+<file path=ppt/notesSlides/notesSlide19.xml><?xml version="1.0" encoding="utf-8"?>
+<p:notes xmlns:a="http://schemas.openxmlformats.org/drawingml/2006/main" xmlns:p="http://schemas.openxmlformats.org/presentationml/2006/main" xmlns:r="http://schemas.openxmlformats.org/officeDocument/2006/relationships">
+  <p:cSld>
+    <p:spTree>
+      <p:nvGrpSpPr>
+        <p:cNvPr id="1" name=""/>
+        <p:cNvGrpSpPr/>
+        <p:nvPr/>
+      </p:nvGrpSpPr>
+      <p:grpSpPr>
+        <a:xfrm>
+          <a:off x="0" y="0"/>
+          <a:ext cx="0" cy="0"/>
+          <a:chOff x="0" y="0"/>
+          <a:chExt cx="0" cy="0"/>
+        </a:xfrm>
+      </p:grpSpPr>
+      <p:sp>
+        <p:nvSpPr>
+          <p:cNvPr id="2" name="Slide Image Placeholder 1"/>
+          <p:cNvSpPr>
+            <a:spLocks noGrp="1"/>
+          </p:cNvSpPr>
+          <p:nvPr>
+            <p:ph type="sldImg" idx="2"/>
+          </p:nvPr>
+        </p:nvSpPr>
+        <p:spPr/>
+      </p:sp>
+      <p:sp>
+        <p:nvSpPr>
+          <p:cNvPr id="3" name="Notes Placeholder 2"/>
+          <p:cNvSpPr>
+            <a:spLocks noGrp="1"/>
+          </p:cNvSpPr>
+          <p:nvPr>
+            <p:ph type="body" idx="3" sz="quarter"/>
+          </p:nvPr>
+        </p:nvSpPr>
+        <p:spPr/>
+        <p:txBody>
+          <a:bodyPr/>
+          <a:lstStyle/>
+          <a:p>
+            <a:r>
+              <a:t>Demo on yourself first so the room sees the ball move before any volunteer. Headset fit takes ~1-2 minutes; keep alcohol wipes + fit-quality checklist within reach. Framing while it runs: 'This is noisier than the fMRI data you saw earlier -- that's expected, exactly what we spent the whole talk characterizing. Watch the trend over the run, not moment-to-moment jitter.' Pre-empts the obvious 'it's jittery' reaction.</a:t>
+            </a:r>
+          </a:p>
+        </p:txBody>
+      </p:sp>
+      <p:sp>
+        <p:nvSpPr>
+          <p:cNvPr id="4" name="Slide Number Placeholder 3"/>
+          <p:cNvSpPr>
+            <a:spLocks noGrp="1"/>
+          </p:cNvSpPr>
+          <p:nvPr>
+            <p:ph type="sldNum" idx="5" sz="quarter"/>
+          </p:nvPr>
+        </p:nvSpPr>
+        <p:spPr/>
+      </p:sp>
+    </p:spTree>
+  </p:cSld>
+  <p:clrMapOvr>
+    <a:masterClrMapping/>
+  </p:clrMapOvr>
+</p:notes>
+</file>
+
+<file path=ppt/notesSlides/notesSlide2.xml><?xml version="1.0" encoding="utf-8"?>
+<p:notes xmlns:a="http://schemas.openxmlformats.org/drawingml/2006/main" xmlns:p="http://schemas.openxmlformats.org/presentationml/2006/main" xmlns:r="http://schemas.openxmlformats.org/officeDocument/2006/relationships">
+  <p:cSld>
+    <p:spTree>
+      <p:nvGrpSpPr>
+        <p:cNvPr id="1" name=""/>
+        <p:cNvGrpSpPr/>
+        <p:nvPr/>
+      </p:nvGrpSpPr>
+      <p:grpSpPr>
+        <a:xfrm>
+          <a:off x="0" y="0"/>
+          <a:ext cx="0" cy="0"/>
+          <a:chOff x="0" y="0"/>
+          <a:chExt cx="0" cy="0"/>
+        </a:xfrm>
+      </p:grpSpPr>
+      <p:sp>
+        <p:nvSpPr>
+          <p:cNvPr id="2" name="Slide Image Placeholder 1"/>
+          <p:cNvSpPr>
+            <a:spLocks noGrp="1"/>
+          </p:cNvSpPr>
+          <p:nvPr>
+            <p:ph type="sldImg" idx="2"/>
+          </p:nvPr>
+        </p:nvSpPr>
+        <p:spPr/>
+      </p:sp>
+      <p:sp>
+        <p:nvSpPr>
+          <p:cNvPr id="3" name="Notes Placeholder 2"/>
+          <p:cNvSpPr>
+            <a:spLocks noGrp="1"/>
+          </p:cNvSpPr>
+          <p:nvPr>
+            <p:ph type="body" idx="3" sz="quarter"/>
+          </p:nvPr>
+        </p:nvSpPr>
+        <p:spPr/>
+        <p:txBody>
+          <a:bodyPr/>
+          <a:lstStyle/>
+          <a:p>
+            <a:r>
+              <a:t>Facilitation: ask the room to close their eyes or soften their gaze; say you'll do this together in silence and you'll tell them when it's over -- don't narrate the phases as they happen. Part 1 (30s): just breathe. Part 2 (2.5 min): bring to mind something unresolved -- a decision you're unsure about, an interaction that didn't go the way you wanted, something still bothering you. Don't try to solve it, just stay with it. Keep time silently (phone, not a visible countdown) -- don't narrate once part 2 starts.</a:t>
+            </a:r>
+          </a:p>
+        </p:txBody>
+      </p:sp>
+      <p:sp>
+        <p:nvSpPr>
+          <p:cNvPr id="4" name="Slide Number Placeholder 3"/>
+          <p:cNvSpPr>
+            <a:spLocks noGrp="1"/>
+          </p:cNvSpPr>
+          <p:nvPr>
+            <p:ph type="sldNum" idx="5" sz="quarter"/>
+          </p:nvPr>
+        </p:nvSpPr>
+        <p:spPr/>
+      </p:sp>
+    </p:spTree>
+  </p:cSld>
+  <p:clrMapOvr>
+    <a:masterClrMapping/>
+  </p:clrMapOvr>
+</p:notes>
+</file>
+
+<file path=ppt/notesSlides/notesSlide20.xml><?xml version="1.0" encoding="utf-8"?>
+<p:notes xmlns:a="http://schemas.openxmlformats.org/drawingml/2006/main" xmlns:p="http://schemas.openxmlformats.org/presentationml/2006/main" xmlns:r="http://schemas.openxmlformats.org/officeDocument/2006/relationships">
+  <p:cSld>
+    <p:spTree>
+      <p:nvGrpSpPr>
+        <p:cNvPr id="1" name=""/>
+        <p:cNvGrpSpPr/>
+        <p:nvPr/>
+      </p:nvGrpSpPr>
+      <p:grpSpPr>
+        <a:xfrm>
+          <a:off x="0" y="0"/>
+          <a:ext cx="0" cy="0"/>
+          <a:chOff x="0" y="0"/>
+          <a:chExt cx="0" cy="0"/>
+        </a:xfrm>
+      </p:grpSpPr>
+      <p:sp>
+        <p:nvSpPr>
+          <p:cNvPr id="2" name="Slide Image Placeholder 1"/>
+          <p:cNvSpPr>
+            <a:spLocks noGrp="1"/>
+          </p:cNvSpPr>
+          <p:nvPr>
+            <p:ph type="sldImg" idx="2"/>
+          </p:nvPr>
+        </p:nvSpPr>
+        <p:spPr/>
+      </p:sp>
+      <p:sp>
+        <p:nvSpPr>
+          <p:cNvPr id="3" name="Notes Placeholder 2"/>
+          <p:cNvSpPr>
+            <a:spLocks noGrp="1"/>
+          </p:cNvSpPr>
+          <p:nvPr>
+            <p:ph type="body" idx="3" sz="quarter"/>
+          </p:nvPr>
+        </p:nvSpPr>
+        <p:spPr/>
+        <p:txBody>
+          <a:bodyPr/>
+          <a:lstStyle/>
+          <a:p>
+            <a:r>
+              <a:t>One sentence each: replication succeeded (within-subject, LOSO, and cross-cohort for CEN/DMN) -&gt; that validated fingerprint now powers mindwear, a portable scanner-free tool -&gt; next is scaling access to DMN-targeted self-regulation training beyond the scanner.</a:t>
+            </a:r>
+          </a:p>
+        </p:txBody>
+      </p:sp>
+      <p:sp>
+        <p:nvSpPr>
+          <p:cNvPr id="4" name="Slide Number Placeholder 3"/>
+          <p:cNvSpPr>
+            <a:spLocks noGrp="1"/>
+          </p:cNvSpPr>
+          <p:nvPr>
+            <p:ph type="sldNum" idx="5" sz="quarter"/>
+          </p:nvPr>
+        </p:nvSpPr>
+        <p:spPr/>
+      </p:sp>
+    </p:spTree>
+  </p:cSld>
+  <p:clrMapOvr>
+    <a:masterClrMapping/>
+  </p:clrMapOvr>
+</p:notes>
+</file>
+
+<file path=ppt/notesSlides/notesSlide21.xml><?xml version="1.0" encoding="utf-8"?>
+<p:notes xmlns:a="http://schemas.openxmlformats.org/drawingml/2006/main" xmlns:p="http://schemas.openxmlformats.org/presentationml/2006/main" xmlns:r="http://schemas.openxmlformats.org/officeDocument/2006/relationships">
+  <p:cSld>
+    <p:spTree>
+      <p:nvGrpSpPr>
+        <p:cNvPr id="1" name=""/>
+        <p:cNvGrpSpPr/>
+        <p:nvPr/>
+      </p:nvGrpSpPr>
+      <p:grpSpPr>
+        <a:xfrm>
+          <a:off x="0" y="0"/>
+          <a:ext cx="0" cy="0"/>
+          <a:chOff x="0" y="0"/>
+          <a:chExt cx="0" cy="0"/>
+        </a:xfrm>
+      </p:grpSpPr>
+      <p:sp>
+        <p:nvSpPr>
+          <p:cNvPr id="2" name="Slide Image Placeholder 1"/>
+          <p:cNvSpPr>
+            <a:spLocks noGrp="1"/>
+          </p:cNvSpPr>
+          <p:nvPr>
+            <p:ph type="sldImg" idx="2"/>
+          </p:nvPr>
+        </p:nvSpPr>
+        <p:spPr/>
+      </p:sp>
+      <p:sp>
+        <p:nvSpPr>
+          <p:cNvPr id="3" name="Notes Placeholder 2"/>
+          <p:cNvSpPr>
+            <a:spLocks noGrp="1"/>
+          </p:cNvSpPr>
+          <p:nvPr>
+            <p:ph type="body" idx="3" sz="quarter"/>
+          </p:nvPr>
+        </p:nvSpPr>
+        <p:spPr/>
+        <p:txBody>
+          <a:bodyPr/>
+          <a:lstStyle/>
+          <a:p>
+            <a:r>
+              <a:t>Bauer et al. (2025), Psychiatry Research: Neuroimaging 353:112050. Same recipe -- real-time fMRI neurofeedback from a symptom-relevant region + the same 'mental-noting' mindfulness technique -- tested in schizophrenia patients with treatment-resistant auditory hallucinations, targeting STG instead of DMN/CEN. Randomized, sham-controlled (n=23): real feedback produced significantly greater reductions in secondary auditory cortex activity and its connectivity to prefrontal control regions than sham. Hallucination severity dropped in both groups, but only real region-specific feedback changed the underlying circuit -- same logic for why targeting DMN/CEN specifically (not generic relaxation) should matter. Together with slide 7, this is a second independent population/region where the same framework produced measurable brain change.</a:t>
+            </a:r>
+          </a:p>
+        </p:txBody>
+      </p:sp>
+      <p:sp>
+        <p:nvSpPr>
+          <p:cNvPr id="4" name="Slide Number Placeholder 3"/>
+          <p:cNvSpPr>
+            <a:spLocks noGrp="1"/>
+          </p:cNvSpPr>
+          <p:nvPr>
+            <p:ph type="sldNum" idx="5" sz="quarter"/>
+          </p:nvPr>
+        </p:nvSpPr>
+        <p:spPr/>
+      </p:sp>
+    </p:spTree>
+  </p:cSld>
+  <p:clrMapOvr>
+    <a:masterClrMapping/>
+  </p:clrMapOvr>
+</p:notes>
+</file>
+
+<file path=ppt/notesSlides/notesSlide3.xml><?xml version="1.0" encoding="utf-8"?>
+<p:notes xmlns:a="http://schemas.openxmlformats.org/drawingml/2006/main" xmlns:p="http://schemas.openxmlformats.org/presentationml/2006/main" xmlns:r="http://schemas.openxmlformats.org/officeDocument/2006/relationships">
+  <p:cSld>
+    <p:spTree>
+      <p:nvGrpSpPr>
+        <p:cNvPr id="1" name=""/>
+        <p:cNvGrpSpPr/>
+        <p:nvPr/>
+      </p:nvGrpSpPr>
+      <p:grpSpPr>
+        <a:xfrm>
+          <a:off x="0" y="0"/>
+          <a:ext cx="0" cy="0"/>
+          <a:chOff x="0" y="0"/>
+          <a:chExt cx="0" cy="0"/>
+        </a:xfrm>
+      </p:grpSpPr>
+      <p:sp>
+        <p:nvSpPr>
+          <p:cNvPr id="2" name="Slide Image Placeholder 1"/>
+          <p:cNvSpPr>
+            <a:spLocks noGrp="1"/>
+          </p:cNvSpPr>
+          <p:nvPr>
+            <p:ph type="sldImg" idx="2"/>
+          </p:nvPr>
+        </p:nvSpPr>
+        <p:spPr/>
+      </p:sp>
+      <p:sp>
+        <p:nvSpPr>
+          <p:cNvPr id="3" name="Notes Placeholder 2"/>
+          <p:cNvSpPr>
+            <a:spLocks noGrp="1"/>
+          </p:cNvSpPr>
+          <p:nvPr>
+            <p:ph type="body" idx="3" sz="quarter"/>
+          </p:nvPr>
+        </p:nvSpPr>
+        <p:spPr/>
+        <p:txBody>
+          <a:bodyPr/>
+          <a:lstStyle/>
+          <a:p>
+            <a:r>
+              <a:t>Bring the room back gently. Don't ask 'how was that' yet -- ask 'what did you notice?' and take 2-3 answers before explaining anything. Expect: racing thoughts, replaying the scenario, self-judgment, losing the thread of the instruction. That's the point -- nobody chose to ruminate, it happened automatically. Bridge line: 'What you just experienced -- unprompted, self-referential, looping thought -- has a name in neuroscience: the Default Mode Network. It's called default because, left with nothing else to do, that's where the brain goes.'</a:t>
+            </a:r>
+          </a:p>
+        </p:txBody>
+      </p:sp>
+      <p:sp>
+        <p:nvSpPr>
+          <p:cNvPr id="4" name="Slide Number Placeholder 3"/>
+          <p:cNvSpPr>
+            <a:spLocks noGrp="1"/>
+          </p:cNvSpPr>
+          <p:nvPr>
+            <p:ph type="sldNum" idx="5" sz="quarter"/>
+          </p:nvPr>
+        </p:nvSpPr>
+        <p:spPr/>
+      </p:sp>
+    </p:spTree>
+  </p:cSld>
+  <p:clrMapOvr>
+    <a:masterClrMapping/>
+  </p:clrMapOvr>
+</p:notes>
+</file>
+
+<file path=ppt/notesSlides/notesSlide4.xml><?xml version="1.0" encoding="utf-8"?>
+<p:notes xmlns:a="http://schemas.openxmlformats.org/drawingml/2006/main" xmlns:p="http://schemas.openxmlformats.org/presentationml/2006/main" xmlns:r="http://schemas.openxmlformats.org/officeDocument/2006/relationships">
+  <p:cSld>
+    <p:spTree>
+      <p:nvGrpSpPr>
+        <p:cNvPr id="1" name=""/>
+        <p:cNvGrpSpPr/>
+        <p:nvPr/>
+      </p:nvGrpSpPr>
+      <p:grpSpPr>
+        <a:xfrm>
+          <a:off x="0" y="0"/>
+          <a:ext cx="0" cy="0"/>
+          <a:chOff x="0" y="0"/>
+          <a:chExt cx="0" cy="0"/>
+        </a:xfrm>
+      </p:grpSpPr>
+      <p:sp>
+        <p:nvSpPr>
+          <p:cNvPr id="2" name="Slide Image Placeholder 1"/>
+          <p:cNvSpPr>
+            <a:spLocks noGrp="1"/>
+          </p:cNvSpPr>
+          <p:nvPr>
+            <p:ph type="sldImg" idx="2"/>
+          </p:nvPr>
+        </p:nvSpPr>
+        <p:spPr/>
+      </p:sp>
+      <p:sp>
+        <p:nvSpPr>
+          <p:cNvPr id="3" name="Notes Placeholder 2"/>
+          <p:cNvSpPr>
+            <a:spLocks noGrp="1"/>
+          </p:cNvSpPr>
+          <p:nvPr>
+            <p:ph type="body" idx="3" sz="quarter"/>
+          </p:nvPr>
+        </p:nvSpPr>
+        <p:spPr/>
+        <p:txBody>
+          <a:bodyPr/>
+          <a:lstStyle/>
+          <a:p>
+            <a:r>
+              <a:t>DMN activity rises when we're not engaged in an external task -- mind-wandering, self-referential thought, autobiographical memory; the room just generated some on purpose. When that pattern gets stuck it's rumination, a cross-cutting feature of depression and anxiety, not a niche symptom. Add your own citations/prevalence numbers on this slide before presenting (left as a placeholder deliberately). Land on: can people learn to quiet this network on demand?</a:t>
+            </a:r>
+          </a:p>
+        </p:txBody>
+      </p:sp>
+      <p:sp>
+        <p:nvSpPr>
+          <p:cNvPr id="4" name="Slide Number Placeholder 3"/>
+          <p:cNvSpPr>
+            <a:spLocks noGrp="1"/>
+          </p:cNvSpPr>
+          <p:nvPr>
+            <p:ph type="sldNum" idx="5" sz="quarter"/>
+          </p:nvPr>
+        </p:nvSpPr>
+        <p:spPr/>
+      </p:sp>
+    </p:spTree>
+  </p:cSld>
+  <p:clrMapOvr>
+    <a:masterClrMapping/>
+  </p:clrMapOvr>
+</p:notes>
+</file>
+
+<file path=ppt/notesSlides/notesSlide5.xml><?xml version="1.0" encoding="utf-8"?>
+<p:notes xmlns:a="http://schemas.openxmlformats.org/drawingml/2006/main" xmlns:p="http://schemas.openxmlformats.org/presentationml/2006/main" xmlns:r="http://schemas.openxmlformats.org/officeDocument/2006/relationships">
+  <p:cSld>
+    <p:spTree>
+      <p:nvGrpSpPr>
+        <p:cNvPr id="1" name=""/>
+        <p:cNvGrpSpPr/>
+        <p:nvPr/>
+      </p:nvGrpSpPr>
+      <p:grpSpPr>
+        <a:xfrm>
+          <a:off x="0" y="0"/>
+          <a:ext cx="0" cy="0"/>
+          <a:chOff x="0" y="0"/>
+          <a:chExt cx="0" cy="0"/>
+        </a:xfrm>
+      </p:grpSpPr>
+      <p:sp>
+        <p:nvSpPr>
+          <p:cNvPr id="2" name="Slide Image Placeholder 1"/>
+          <p:cNvSpPr>
+            <a:spLocks noGrp="1"/>
+          </p:cNvSpPr>
+          <p:nvPr>
+            <p:ph type="sldImg" idx="2"/>
+          </p:nvPr>
+        </p:nvSpPr>
+        <p:spPr/>
+      </p:sp>
+      <p:sp>
+        <p:nvSpPr>
+          <p:cNvPr id="3" name="Notes Placeholder 2"/>
+          <p:cNvSpPr>
+            <a:spLocks noGrp="1"/>
+          </p:cNvSpPr>
+          <p:nvPr>
+            <p:ph type="body" idx="3" sz="quarter"/>
+          </p:nvPr>
+        </p:nvSpPr>
+        <p:spPr/>
+        <p:txBody>
+          <a:bodyPr/>
+          <a:lstStyle/>
+          <a:p>
+            <a:r>
+              <a:t>Mindfulness practice is associated with reduced DMN activity and altered connectivity, at rest and during tasks -- meditators have effectively trained themselves to do, at will, something like the reverse of what the room just experienced involuntarily. Add your preferred primary source (e.g. Brewer et al. 2011 PNAS) on this slide. The catch: normally takes months to years of practice before it generalizes -- that's the opening for neurofeedback as a shortcut.</a:t>
+            </a:r>
+          </a:p>
+        </p:txBody>
+      </p:sp>
+      <p:sp>
+        <p:nvSpPr>
+          <p:cNvPr id="4" name="Slide Number Placeholder 3"/>
+          <p:cNvSpPr>
+            <a:spLocks noGrp="1"/>
+          </p:cNvSpPr>
+          <p:nvPr>
+            <p:ph type="sldNum" idx="5" sz="quarter"/>
+          </p:nvPr>
+        </p:nvSpPr>
+        <p:spPr/>
+      </p:sp>
+    </p:spTree>
+  </p:cSld>
+  <p:clrMapOvr>
+    <a:masterClrMapping/>
+  </p:clrMapOvr>
+</p:notes>
+</file>
+
+<file path=ppt/notesSlides/notesSlide6.xml><?xml version="1.0" encoding="utf-8"?>
+<p:notes xmlns:a="http://schemas.openxmlformats.org/drawingml/2006/main" xmlns:p="http://schemas.openxmlformats.org/presentationml/2006/main" xmlns:r="http://schemas.openxmlformats.org/officeDocument/2006/relationships">
+  <p:cSld>
+    <p:spTree>
+      <p:nvGrpSpPr>
+        <p:cNvPr id="1" name=""/>
+        <p:cNvGrpSpPr/>
+        <p:nvPr/>
+      </p:nvGrpSpPr>
+      <p:grpSpPr>
+        <a:xfrm>
+          <a:off x="0" y="0"/>
+          <a:ext cx="0" cy="0"/>
+          <a:chOff x="0" y="0"/>
+          <a:chExt cx="0" cy="0"/>
+        </a:xfrm>
+      </p:grpSpPr>
+      <p:sp>
+        <p:nvSpPr>
+          <p:cNvPr id="2" name="Slide Image Placeholder 1"/>
+          <p:cNvSpPr>
+            <a:spLocks noGrp="1"/>
+          </p:cNvSpPr>
+          <p:nvPr>
+            <p:ph type="sldImg" idx="2"/>
+          </p:nvPr>
+        </p:nvSpPr>
+        <p:spPr/>
+      </p:sp>
+      <p:sp>
+        <p:nvSpPr>
+          <p:cNvPr id="3" name="Notes Placeholder 2"/>
+          <p:cNvSpPr>
+            <a:spLocks noGrp="1"/>
+          </p:cNvSpPr>
+          <p:nvPr>
+            <p:ph type="body" idx="3" sz="quarter"/>
+          </p:nvPr>
+        </p:nvSpPr>
+        <p:spPr/>
+        <p:txBody>
+          <a:bodyPr/>
+          <a:lstStyle/>
+          <a:p>
+            <a:r>
+              <a:t>Real-time neurofeedback gives someone a direct, immediate readout of their own brain state. The hypothesis: seeing your DMN/CEN balance moment to moment lets you learn to shift it far faster than practice alone. Introduce the visual ball task here: it rises toward CEN when task-focused attention dominates, toward DMN otherwise -- this is the exact mechanic used in every result on the following slides.</a:t>
+            </a:r>
+          </a:p>
+        </p:txBody>
+      </p:sp>
+      <p:sp>
+        <p:nvSpPr>
+          <p:cNvPr id="4" name="Slide Number Placeholder 3"/>
+          <p:cNvSpPr>
+            <a:spLocks noGrp="1"/>
+          </p:cNvSpPr>
+          <p:nvPr>
+            <p:ph type="sldNum" idx="5" sz="quarter"/>
+          </p:nvPr>
+        </p:nvSpPr>
+        <p:spPr/>
+      </p:sp>
+    </p:spTree>
+  </p:cSld>
+  <p:clrMapOvr>
+    <a:masterClrMapping/>
+  </p:clrMapOvr>
+</p:notes>
+</file>
+
+<file path=ppt/notesSlides/notesSlide7.xml><?xml version="1.0" encoding="utf-8"?>
+<p:notes xmlns:a="http://schemas.openxmlformats.org/drawingml/2006/main" xmlns:p="http://schemas.openxmlformats.org/presentationml/2006/main" xmlns:r="http://schemas.openxmlformats.org/officeDocument/2006/relationships">
+  <p:cSld>
+    <p:spTree>
+      <p:nvGrpSpPr>
+        <p:cNvPr id="1" name=""/>
+        <p:cNvGrpSpPr/>
+        <p:nvPr/>
+      </p:nvGrpSpPr>
+      <p:grpSpPr>
+        <a:xfrm>
+          <a:off x="0" y="0"/>
+          <a:ext cx="0" cy="0"/>
+          <a:chOff x="0" y="0"/>
+          <a:chExt cx="0" cy="0"/>
+        </a:xfrm>
+      </p:grpSpPr>
+      <p:sp>
+        <p:nvSpPr>
+          <p:cNvPr id="2" name="Slide Image Placeholder 1"/>
+          <p:cNvSpPr>
+            <a:spLocks noGrp="1"/>
+          </p:cNvSpPr>
+          <p:nvPr>
+            <p:ph type="sldImg" idx="2"/>
+          </p:nvPr>
+        </p:nvSpPr>
+        <p:spPr/>
+      </p:sp>
+      <p:sp>
+        <p:nvSpPr>
+          <p:cNvPr id="3" name="Notes Placeholder 2"/>
+          <p:cNvSpPr>
+            <a:spLocks noGrp="1"/>
+          </p:cNvSpPr>
+          <p:nvPr>
+            <p:ph type="body" idx="3" sz="quarter"/>
+          </p:nvPr>
+        </p:nvSpPr>
+        <p:spPr/>
+        <p:txBody>
+          <a:bodyPr/>
+          <a:lstStyle/>
+          <a:p>
+            <a:r>
+              <a:t>Zhang, Raya, Morfini, ... Bauer, Whitfield-Gabrieli (2023), Molecular Psychiatry. 9 adolescents with a lifetime history of depression/anxiety; DMN/CEN individually localized per person. One 15-minute mbNF session, using PDA = CEN activation - DMN activation -- the exact same metric and dot/ball mechanic used throughout this talk and in mindwear. Result: participants spent significantly more time in the target state than chance (p=.038); ALL 9 of 9 adolescents showed reduced within-DMN connectivity after just one session; that reduction correlated with increased state mindfulness (r=-0.88, p=.002) and statistically mediated the performance-to-mindfulness link. This is the evidence base that motivates scaling the same paradigm outside the scanner.</a:t>
+            </a:r>
+          </a:p>
+        </p:txBody>
+      </p:sp>
+      <p:sp>
+        <p:nvSpPr>
+          <p:cNvPr id="4" name="Slide Number Placeholder 3"/>
+          <p:cNvSpPr>
+            <a:spLocks noGrp="1"/>
+          </p:cNvSpPr>
+          <p:nvPr>
+            <p:ph type="sldNum" idx="5" sz="quarter"/>
+          </p:nvPr>
+        </p:nvSpPr>
+        <p:spPr/>
+      </p:sp>
+    </p:spTree>
+  </p:cSld>
+  <p:clrMapOvr>
+    <a:masterClrMapping/>
+  </p:clrMapOvr>
+</p:notes>
+</file>
+
+<file path=ppt/notesSlides/notesSlide8.xml><?xml version="1.0" encoding="utf-8"?>
+<p:notes xmlns:a="http://schemas.openxmlformats.org/drawingml/2006/main" xmlns:p="http://schemas.openxmlformats.org/presentationml/2006/main" xmlns:r="http://schemas.openxmlformats.org/officeDocument/2006/relationships">
+  <p:cSld>
+    <p:spTree>
+      <p:nvGrpSpPr>
+        <p:cNvPr id="1" name=""/>
+        <p:cNvGrpSpPr/>
+        <p:nvPr/>
+      </p:nvGrpSpPr>
+      <p:grpSpPr>
+        <a:xfrm>
+          <a:off x="0" y="0"/>
+          <a:ext cx="0" cy="0"/>
+          <a:chOff x="0" y="0"/>
+          <a:chExt cx="0" cy="0"/>
+        </a:xfrm>
+      </p:grpSpPr>
+      <p:sp>
+        <p:nvSpPr>
+          <p:cNvPr id="2" name="Slide Image Placeholder 1"/>
+          <p:cNvSpPr>
+            <a:spLocks noGrp="1"/>
+          </p:cNvSpPr>
+          <p:nvPr>
+            <p:ph type="sldImg" idx="2"/>
+          </p:nvPr>
+        </p:nvSpPr>
+        <p:spPr/>
+      </p:sp>
+      <p:sp>
+        <p:nvSpPr>
+          <p:cNvPr id="3" name="Notes Placeholder 2"/>
+          <p:cNvSpPr>
+            <a:spLocks noGrp="1"/>
+          </p:cNvSpPr>
+          <p:nvPr>
+            <p:ph type="body" idx="3" sz="quarter"/>
+          </p:nvPr>
+        </p:nvSpPr>
+        <p:spPr/>
+        <p:txBody>
+          <a:bodyPr/>
+          <a:lstStyle/>
+          <a:p>
+            <a:r>
+              <a:t>fMRI neurofeedback works, but a scanner is expensive, immobile, and inaccessible for repeated/at-home/clinical use. If this is going to reach people beyond one research scanner, we need the SAME signal decodable from something portable. EEG is cheap and real-time but doesn't measure DMN/CEN BOLD directly -- it has to be decoded. That decoding problem is the rest of the talk.</a:t>
+            </a:r>
+          </a:p>
+        </p:txBody>
+      </p:sp>
+      <p:sp>
+        <p:nvSpPr>
+          <p:cNvPr id="4" name="Slide Number Placeholder 3"/>
+          <p:cNvSpPr>
+            <a:spLocks noGrp="1"/>
+          </p:cNvSpPr>
+          <p:nvPr>
+            <p:ph type="sldNum" idx="5" sz="quarter"/>
+          </p:nvPr>
+        </p:nvSpPr>
+        <p:spPr/>
+      </p:sp>
+    </p:spTree>
+  </p:cSld>
+  <p:clrMapOvr>
+    <a:masterClrMapping/>
+  </p:clrMapOvr>
+</p:notes>
+</file>
+
+<file path=ppt/notesSlides/notesSlide9.xml><?xml version="1.0" encoding="utf-8"?>
+<p:notes xmlns:a="http://schemas.openxmlformats.org/drawingml/2006/main" xmlns:p="http://schemas.openxmlformats.org/presentationml/2006/main" xmlns:r="http://schemas.openxmlformats.org/officeDocument/2006/relationships">
+  <p:cSld>
+    <p:spTree>
+      <p:nvGrpSpPr>
+        <p:cNvPr id="1" name=""/>
+        <p:cNvGrpSpPr/>
+        <p:nvPr/>
+      </p:nvGrpSpPr>
+      <p:grpSpPr>
+        <a:xfrm>
+          <a:off x="0" y="0"/>
+          <a:ext cx="0" cy="0"/>
+          <a:chOff x="0" y="0"/>
+          <a:chExt cx="0" cy="0"/>
+        </a:xfrm>
+      </p:grpSpPr>
+      <p:sp>
+        <p:nvSpPr>
+          <p:cNvPr id="2" name="Slide Image Placeholder 1"/>
+          <p:cNvSpPr>
+            <a:spLocks noGrp="1"/>
+          </p:cNvSpPr>
+          <p:nvPr>
+            <p:ph type="sldImg" idx="2"/>
+          </p:nvPr>
+        </p:nvSpPr>
+        <p:spPr/>
+      </p:sp>
+      <p:sp>
+        <p:nvSpPr>
+          <p:cNvPr id="3" name="Notes Placeholder 2"/>
+          <p:cNvSpPr>
+            <a:spLocks noGrp="1"/>
+          </p:cNvSpPr>
+          <p:nvPr>
+            <p:ph type="body" idx="3" sz="quarter"/>
+          </p:nvPr>
+        </p:nvSpPr>
+        <p:spPr/>
+        <p:txBody>
+          <a:bodyPr/>
+          <a:lstStyle/>
+          <a:p>
+            <a:r>
+              <a:t>Meir-Hasson et al. (2014), NeuroImage 102:128-141. Goal: predict fMRI BOLD in a specific ROI (they focused on the amygdala) from simultaneous EEG, well enough to eventually let portable EEG stand in for the scanner. Core method we replicate: single electrode -&gt; Stockwell time-frequency transform -&gt; 10 data-driven equal-energy frequency bands (not fixed alpha/theta) -&gt; ridge regression on a [band x sliding time-delay] design. Key innovation: no fixed hemodynamic delay -- each frequency band gets its own data-driven delay, per subject and electrode. Validated with double cross-validation (same discipline our own replication follows).</a:t>
+            </a:r>
+          </a:p>
+        </p:txBody>
+      </p:sp>
+      <p:sp>
+        <p:nvSpPr>
+          <p:cNvPr id="4" name="Slide Number Placeholder 3"/>
+          <p:cNvSpPr>
+            <a:spLocks noGrp="1"/>
+          </p:cNvSpPr>
+          <p:nvPr>
+            <p:ph type="sldNum" idx="5" sz="quarter"/>
+          </p:nvPr>
+        </p:nvSpPr>
+        <p:spPr/>
+      </p:sp>
+    </p:spTree>
+  </p:cSld>
+  <p:clrMapOvr>
+    <a:masterClrMapping/>
+  </p:clrMapOvr>
+</p:notes>
 </file>
 
 <file path=ppt/slideLayouts/slideLayout1.xml><?xml version="1.0" encoding="utf-8"?>
@@ -165,10 +2001,9 @@
           <a:lstStyle/>
           <a:p>
             <a:r>
-              <a:rPr lang="en-US" smtClean="0"/>
+              <a:rPr lang="en-US"/>
               <a:t>Click to edit Master title style</a:t>
             </a:r>
-            <a:endParaRPr lang="en-US"/>
           </a:p>
         </p:txBody>
       </p:sp>
@@ -284,10 +2119,9 @@
           </a:lstStyle>
           <a:p>
             <a:r>
-              <a:rPr lang="en-US" smtClean="0"/>
+              <a:rPr lang="en-US"/>
               <a:t>Click to edit Master subtitle style</a:t>
             </a:r>
-            <a:endParaRPr lang="en-US"/>
           </a:p>
         </p:txBody>
       </p:sp>
@@ -308,7 +2142,7 @@
           <a:p>
             <a:fld id="{5BCAD085-E8A6-8845-BD4E-CB4CCA059FC4}" type="datetimeFigureOut">
               <a:rPr lang="en-US" smtClean="0"/>
-              <a:t>1/27/13</a:t>
+              <a:t>9/1/26</a:t>
             </a:fld>
             <a:endParaRPr lang="en-US"/>
           </a:p>
@@ -402,10 +2236,9 @@
           <a:lstStyle/>
           <a:p>
             <a:r>
-              <a:rPr lang="en-US" smtClean="0"/>
+              <a:rPr lang="en-US"/>
               <a:t>Click to edit Master title style</a:t>
             </a:r>
-            <a:endParaRPr lang="en-US"/>
           </a:p>
         </p:txBody>
       </p:sp>
@@ -426,38 +2259,37 @@
           <a:p>
             <a:pPr lvl="0"/>
             <a:r>
-              <a:rPr lang="en-US" smtClean="0"/>
+              <a:rPr lang="en-US"/>
               <a:t>Click to edit Master text styles</a:t>
             </a:r>
           </a:p>
           <a:p>
             <a:pPr lvl="1"/>
             <a:r>
-              <a:rPr lang="en-US" smtClean="0"/>
+              <a:rPr lang="en-US"/>
               <a:t>Second level</a:t>
             </a:r>
           </a:p>
           <a:p>
             <a:pPr lvl="2"/>
             <a:r>
-              <a:rPr lang="en-US" smtClean="0"/>
+              <a:rPr lang="en-US"/>
               <a:t>Third level</a:t>
             </a:r>
           </a:p>
           <a:p>
             <a:pPr lvl="3"/>
             <a:r>
-              <a:rPr lang="en-US" smtClean="0"/>
+              <a:rPr lang="en-US"/>
               <a:t>Fourth level</a:t>
             </a:r>
           </a:p>
           <a:p>
             <a:pPr lvl="4"/>
             <a:r>
-              <a:rPr lang="en-US" smtClean="0"/>
+              <a:rPr lang="en-US"/>
               <a:t>Fifth level</a:t>
             </a:r>
-            <a:endParaRPr lang="en-US"/>
           </a:p>
         </p:txBody>
       </p:sp>
@@ -478,7 +2310,7 @@
           <a:p>
             <a:fld id="{5BCAD085-E8A6-8845-BD4E-CB4CCA059FC4}" type="datetimeFigureOut">
               <a:rPr lang="en-US" smtClean="0"/>
-              <a:t>1/27/13</a:t>
+              <a:t>9/1/26</a:t>
             </a:fld>
             <a:endParaRPr lang="en-US"/>
           </a:p>
@@ -577,10 +2409,9 @@
           <a:lstStyle/>
           <a:p>
             <a:r>
-              <a:rPr lang="en-US" smtClean="0"/>
+              <a:rPr lang="en-US"/>
               <a:t>Click to edit Master title style</a:t>
             </a:r>
-            <a:endParaRPr lang="en-US"/>
           </a:p>
         </p:txBody>
       </p:sp>
@@ -606,38 +2437,37 @@
           <a:p>
             <a:pPr lvl="0"/>
             <a:r>
-              <a:rPr lang="en-US" smtClean="0"/>
+              <a:rPr lang="en-US"/>
               <a:t>Click to edit Master text styles</a:t>
             </a:r>
           </a:p>
           <a:p>
             <a:pPr lvl="1"/>
             <a:r>
-              <a:rPr lang="en-US" smtClean="0"/>
+              <a:rPr lang="en-US"/>
               <a:t>Second level</a:t>
             </a:r>
           </a:p>
           <a:p>
             <a:pPr lvl="2"/>
             <a:r>
-              <a:rPr lang="en-US" smtClean="0"/>
+              <a:rPr lang="en-US"/>
               <a:t>Third level</a:t>
             </a:r>
           </a:p>
           <a:p>
             <a:pPr lvl="3"/>
             <a:r>
-              <a:rPr lang="en-US" smtClean="0"/>
+              <a:rPr lang="en-US"/>
               <a:t>Fourth level</a:t>
             </a:r>
           </a:p>
           <a:p>
             <a:pPr lvl="4"/>
             <a:r>
-              <a:rPr lang="en-US" smtClean="0"/>
+              <a:rPr lang="en-US"/>
               <a:t>Fifth level</a:t>
             </a:r>
-            <a:endParaRPr lang="en-US"/>
           </a:p>
         </p:txBody>
       </p:sp>
@@ -658,7 +2488,7 @@
           <a:p>
             <a:fld id="{5BCAD085-E8A6-8845-BD4E-CB4CCA059FC4}" type="datetimeFigureOut">
               <a:rPr lang="en-US" smtClean="0"/>
-              <a:t>1/27/13</a:t>
+              <a:t>9/1/26</a:t>
             </a:fld>
             <a:endParaRPr lang="en-US"/>
           </a:p>
@@ -752,10 +2582,9 @@
           <a:lstStyle/>
           <a:p>
             <a:r>
-              <a:rPr lang="en-US" smtClean="0"/>
+              <a:rPr lang="en-US"/>
               <a:t>Click to edit Master title style</a:t>
             </a:r>
-            <a:endParaRPr lang="en-US"/>
           </a:p>
         </p:txBody>
       </p:sp>
@@ -776,38 +2605,37 @@
           <a:p>
             <a:pPr lvl="0"/>
             <a:r>
-              <a:rPr lang="en-US" smtClean="0"/>
+              <a:rPr lang="en-US"/>
               <a:t>Click to edit Master text styles</a:t>
             </a:r>
           </a:p>
           <a:p>
             <a:pPr lvl="1"/>
             <a:r>
-              <a:rPr lang="en-US" smtClean="0"/>
+              <a:rPr lang="en-US"/>
               <a:t>Second level</a:t>
             </a:r>
           </a:p>
           <a:p>
             <a:pPr lvl="2"/>
             <a:r>
-              <a:rPr lang="en-US" smtClean="0"/>
+              <a:rPr lang="en-US"/>
               <a:t>Third level</a:t>
             </a:r>
           </a:p>
           <a:p>
             <a:pPr lvl="3"/>
             <a:r>
-              <a:rPr lang="en-US" smtClean="0"/>
+              <a:rPr lang="en-US"/>
               <a:t>Fourth level</a:t>
             </a:r>
           </a:p>
           <a:p>
             <a:pPr lvl="4"/>
             <a:r>
-              <a:rPr lang="en-US" smtClean="0"/>
+              <a:rPr lang="en-US"/>
               <a:t>Fifth level</a:t>
             </a:r>
-            <a:endParaRPr lang="en-US"/>
           </a:p>
         </p:txBody>
       </p:sp>
@@ -828,7 +2656,7 @@
           <a:p>
             <a:fld id="{5BCAD085-E8A6-8845-BD4E-CB4CCA059FC4}" type="datetimeFigureOut">
               <a:rPr lang="en-US" smtClean="0"/>
-              <a:t>1/27/13</a:t>
+              <a:t>9/1/26</a:t>
             </a:fld>
             <a:endParaRPr lang="en-US"/>
           </a:p>
@@ -931,10 +2759,9 @@
           </a:lstStyle>
           <a:p>
             <a:r>
-              <a:rPr lang="en-US" smtClean="0"/>
+              <a:rPr lang="en-US"/>
               <a:t>Click to edit Master title style</a:t>
             </a:r>
-            <a:endParaRPr lang="en-US"/>
           </a:p>
         </p:txBody>
       </p:sp>
@@ -1051,7 +2878,7 @@
           <a:p>
             <a:pPr lvl="0"/>
             <a:r>
-              <a:rPr lang="en-US" smtClean="0"/>
+              <a:rPr lang="en-US"/>
               <a:t>Click to edit Master text styles</a:t>
             </a:r>
           </a:p>
@@ -1074,7 +2901,7 @@
           <a:p>
             <a:fld id="{5BCAD085-E8A6-8845-BD4E-CB4CCA059FC4}" type="datetimeFigureOut">
               <a:rPr lang="en-US" smtClean="0"/>
-              <a:t>1/27/13</a:t>
+              <a:t>9/1/26</a:t>
             </a:fld>
             <a:endParaRPr lang="en-US"/>
           </a:p>
@@ -1168,10 +2995,9 @@
           <a:lstStyle/>
           <a:p>
             <a:r>
-              <a:rPr lang="en-US" smtClean="0"/>
+              <a:rPr lang="en-US"/>
               <a:t>Click to edit Master title style</a:t>
             </a:r>
-            <a:endParaRPr lang="en-US"/>
           </a:p>
         </p:txBody>
       </p:sp>
@@ -1225,38 +3051,37 @@
           <a:p>
             <a:pPr lvl="0"/>
             <a:r>
-              <a:rPr lang="en-US" smtClean="0"/>
+              <a:rPr lang="en-US"/>
               <a:t>Click to edit Master text styles</a:t>
             </a:r>
           </a:p>
           <a:p>
             <a:pPr lvl="1"/>
             <a:r>
-              <a:rPr lang="en-US" smtClean="0"/>
+              <a:rPr lang="en-US"/>
               <a:t>Second level</a:t>
             </a:r>
           </a:p>
           <a:p>
             <a:pPr lvl="2"/>
             <a:r>
-              <a:rPr lang="en-US" smtClean="0"/>
+              <a:rPr lang="en-US"/>
               <a:t>Third level</a:t>
             </a:r>
           </a:p>
           <a:p>
             <a:pPr lvl="3"/>
             <a:r>
-              <a:rPr lang="en-US" smtClean="0"/>
+              <a:rPr lang="en-US"/>
               <a:t>Fourth level</a:t>
             </a:r>
           </a:p>
           <a:p>
             <a:pPr lvl="4"/>
             <a:r>
-              <a:rPr lang="en-US" smtClean="0"/>
+              <a:rPr lang="en-US"/>
               <a:t>Fifth level</a:t>
             </a:r>
-            <a:endParaRPr lang="en-US"/>
           </a:p>
         </p:txBody>
       </p:sp>
@@ -1310,38 +3135,37 @@
           <a:p>
             <a:pPr lvl="0"/>
             <a:r>
-              <a:rPr lang="en-US" smtClean="0"/>
+              <a:rPr lang="en-US"/>
               <a:t>Click to edit Master text styles</a:t>
             </a:r>
           </a:p>
           <a:p>
             <a:pPr lvl="1"/>
             <a:r>
-              <a:rPr lang="en-US" smtClean="0"/>
+              <a:rPr lang="en-US"/>
               <a:t>Second level</a:t>
             </a:r>
           </a:p>
           <a:p>
             <a:pPr lvl="2"/>
             <a:r>
-              <a:rPr lang="en-US" smtClean="0"/>
+              <a:rPr lang="en-US"/>
               <a:t>Third level</a:t>
             </a:r>
           </a:p>
           <a:p>
             <a:pPr lvl="3"/>
             <a:r>
-              <a:rPr lang="en-US" smtClean="0"/>
+              <a:rPr lang="en-US"/>
               <a:t>Fourth level</a:t>
             </a:r>
           </a:p>
           <a:p>
             <a:pPr lvl="4"/>
             <a:r>
-              <a:rPr lang="en-US" smtClean="0"/>
+              <a:rPr lang="en-US"/>
               <a:t>Fifth level</a:t>
             </a:r>
-            <a:endParaRPr lang="en-US"/>
           </a:p>
         </p:txBody>
       </p:sp>
@@ -1362,7 +3186,7 @@
           <a:p>
             <a:fld id="{5BCAD085-E8A6-8845-BD4E-CB4CCA059FC4}" type="datetimeFigureOut">
               <a:rPr lang="en-US" smtClean="0"/>
-              <a:t>1/27/13</a:t>
+              <a:t>9/1/26</a:t>
             </a:fld>
             <a:endParaRPr lang="en-US"/>
           </a:p>
@@ -1460,10 +3284,9 @@
           </a:lstStyle>
           <a:p>
             <a:r>
-              <a:rPr lang="en-US" smtClean="0"/>
+              <a:rPr lang="en-US"/>
               <a:t>Click to edit Master title style</a:t>
             </a:r>
-            <a:endParaRPr lang="en-US"/>
           </a:p>
         </p:txBody>
       </p:sp>
@@ -1526,7 +3349,7 @@
           <a:p>
             <a:pPr lvl="0"/>
             <a:r>
-              <a:rPr lang="en-US" smtClean="0"/>
+              <a:rPr lang="en-US"/>
               <a:t>Click to edit Master text styles</a:t>
             </a:r>
           </a:p>
@@ -1582,38 +3405,37 @@
           <a:p>
             <a:pPr lvl="0"/>
             <a:r>
-              <a:rPr lang="en-US" smtClean="0"/>
+              <a:rPr lang="en-US"/>
               <a:t>Click to edit Master text styles</a:t>
             </a:r>
           </a:p>
           <a:p>
             <a:pPr lvl="1"/>
             <a:r>
-              <a:rPr lang="en-US" smtClean="0"/>
+              <a:rPr lang="en-US"/>
               <a:t>Second level</a:t>
             </a:r>
           </a:p>
           <a:p>
             <a:pPr lvl="2"/>
             <a:r>
-              <a:rPr lang="en-US" smtClean="0"/>
+              <a:rPr lang="en-US"/>
               <a:t>Third level</a:t>
             </a:r>
           </a:p>
           <a:p>
             <a:pPr lvl="3"/>
             <a:r>
-              <a:rPr lang="en-US" smtClean="0"/>
+              <a:rPr lang="en-US"/>
               <a:t>Fourth level</a:t>
             </a:r>
           </a:p>
           <a:p>
             <a:pPr lvl="4"/>
             <a:r>
-              <a:rPr lang="en-US" smtClean="0"/>
+              <a:rPr lang="en-US"/>
               <a:t>Fifth level</a:t>
             </a:r>
-            <a:endParaRPr lang="en-US"/>
           </a:p>
         </p:txBody>
       </p:sp>
@@ -1676,7 +3498,7 @@
           <a:p>
             <a:pPr lvl="0"/>
             <a:r>
-              <a:rPr lang="en-US" smtClean="0"/>
+              <a:rPr lang="en-US"/>
               <a:t>Click to edit Master text styles</a:t>
             </a:r>
           </a:p>
@@ -1732,38 +3554,37 @@
           <a:p>
             <a:pPr lvl="0"/>
             <a:r>
-              <a:rPr lang="en-US" smtClean="0"/>
+              <a:rPr lang="en-US"/>
               <a:t>Click to edit Master text styles</a:t>
             </a:r>
           </a:p>
           <a:p>
             <a:pPr lvl="1"/>
             <a:r>
-              <a:rPr lang="en-US" smtClean="0"/>
+              <a:rPr lang="en-US"/>
               <a:t>Second level</a:t>
             </a:r>
           </a:p>
           <a:p>
             <a:pPr lvl="2"/>
             <a:r>
-              <a:rPr lang="en-US" smtClean="0"/>
+              <a:rPr lang="en-US"/>
               <a:t>Third level</a:t>
             </a:r>
           </a:p>
           <a:p>
             <a:pPr lvl="3"/>
             <a:r>
-              <a:rPr lang="en-US" smtClean="0"/>
+              <a:rPr lang="en-US"/>
               <a:t>Fourth level</a:t>
             </a:r>
           </a:p>
           <a:p>
             <a:pPr lvl="4"/>
             <a:r>
-              <a:rPr lang="en-US" smtClean="0"/>
+              <a:rPr lang="en-US"/>
               <a:t>Fifth level</a:t>
             </a:r>
-            <a:endParaRPr lang="en-US"/>
           </a:p>
         </p:txBody>
       </p:sp>
@@ -1784,7 +3605,7 @@
           <a:p>
             <a:fld id="{5BCAD085-E8A6-8845-BD4E-CB4CCA059FC4}" type="datetimeFigureOut">
               <a:rPr lang="en-US" smtClean="0"/>
-              <a:t>1/27/13</a:t>
+              <a:t>9/1/26</a:t>
             </a:fld>
             <a:endParaRPr lang="en-US"/>
           </a:p>
@@ -1878,10 +3699,9 @@
           <a:lstStyle/>
           <a:p>
             <a:r>
-              <a:rPr lang="en-US" smtClean="0"/>
+              <a:rPr lang="en-US"/>
               <a:t>Click to edit Master title style</a:t>
             </a:r>
-            <a:endParaRPr lang="en-US"/>
           </a:p>
         </p:txBody>
       </p:sp>
@@ -1902,7 +3722,7 @@
           <a:p>
             <a:fld id="{5BCAD085-E8A6-8845-BD4E-CB4CCA059FC4}" type="datetimeFigureOut">
               <a:rPr lang="en-US" smtClean="0"/>
-              <a:t>1/27/13</a:t>
+              <a:t>9/1/26</a:t>
             </a:fld>
             <a:endParaRPr lang="en-US"/>
           </a:p>
@@ -1997,7 +3817,7 @@
           <a:p>
             <a:fld id="{5BCAD085-E8A6-8845-BD4E-CB4CCA059FC4}" type="datetimeFigureOut">
               <a:rPr lang="en-US" smtClean="0"/>
-              <a:t>1/27/13</a:t>
+              <a:t>9/1/26</a:t>
             </a:fld>
             <a:endParaRPr lang="en-US"/>
           </a:p>
@@ -2100,10 +3920,9 @@
           </a:lstStyle>
           <a:p>
             <a:r>
-              <a:rPr lang="en-US" smtClean="0"/>
+              <a:rPr lang="en-US"/>
               <a:t>Click to edit Master title style</a:t>
             </a:r>
-            <a:endParaRPr lang="en-US"/>
           </a:p>
         </p:txBody>
       </p:sp>
@@ -2157,38 +3976,37 @@
           <a:p>
             <a:pPr lvl="0"/>
             <a:r>
-              <a:rPr lang="en-US" smtClean="0"/>
+              <a:rPr lang="en-US"/>
               <a:t>Click to edit Master text styles</a:t>
             </a:r>
           </a:p>
           <a:p>
             <a:pPr lvl="1"/>
             <a:r>
-              <a:rPr lang="en-US" smtClean="0"/>
+              <a:rPr lang="en-US"/>
               <a:t>Second level</a:t>
             </a:r>
           </a:p>
           <a:p>
             <a:pPr lvl="2"/>
             <a:r>
-              <a:rPr lang="en-US" smtClean="0"/>
+              <a:rPr lang="en-US"/>
               <a:t>Third level</a:t>
             </a:r>
           </a:p>
           <a:p>
             <a:pPr lvl="3"/>
             <a:r>
-              <a:rPr lang="en-US" smtClean="0"/>
+              <a:rPr lang="en-US"/>
               <a:t>Fourth level</a:t>
             </a:r>
           </a:p>
           <a:p>
             <a:pPr lvl="4"/>
             <a:r>
-              <a:rPr lang="en-US" smtClean="0"/>
+              <a:rPr lang="en-US"/>
               <a:t>Fifth level</a:t>
             </a:r>
-            <a:endParaRPr lang="en-US"/>
           </a:p>
         </p:txBody>
       </p:sp>
@@ -2251,7 +4069,7 @@
           <a:p>
             <a:pPr lvl="0"/>
             <a:r>
-              <a:rPr lang="en-US" smtClean="0"/>
+              <a:rPr lang="en-US"/>
               <a:t>Click to edit Master text styles</a:t>
             </a:r>
           </a:p>
@@ -2274,7 +4092,7 @@
           <a:p>
             <a:fld id="{5BCAD085-E8A6-8845-BD4E-CB4CCA059FC4}" type="datetimeFigureOut">
               <a:rPr lang="en-US" smtClean="0"/>
-              <a:t>1/27/13</a:t>
+              <a:t>9/1/26</a:t>
             </a:fld>
             <a:endParaRPr lang="en-US"/>
           </a:p>
@@ -2377,10 +4195,9 @@
           </a:lstStyle>
           <a:p>
             <a:r>
-              <a:rPr lang="en-US" smtClean="0"/>
+              <a:rPr lang="en-US"/>
               <a:t>Click to edit Master title style</a:t>
             </a:r>
-            <a:endParaRPr lang="en-US"/>
           </a:p>
         </p:txBody>
       </p:sp>
@@ -2504,7 +4321,7 @@
           <a:p>
             <a:pPr lvl="0"/>
             <a:r>
-              <a:rPr lang="en-US" smtClean="0"/>
+              <a:rPr lang="en-US"/>
               <a:t>Click to edit Master text styles</a:t>
             </a:r>
           </a:p>
@@ -2527,7 +4344,7 @@
           <a:p>
             <a:fld id="{5BCAD085-E8A6-8845-BD4E-CB4CCA059FC4}" type="datetimeFigureOut">
               <a:rPr lang="en-US" smtClean="0"/>
-              <a:t>1/27/13</a:t>
+              <a:t>9/1/26</a:t>
             </a:fld>
             <a:endParaRPr lang="en-US"/>
           </a:p>
@@ -2636,10 +4453,9 @@
           <a:lstStyle/>
           <a:p>
             <a:r>
-              <a:rPr lang="en-US" smtClean="0"/>
+              <a:rPr lang="en-US"/>
               <a:t>Click to edit Master title style</a:t>
             </a:r>
-            <a:endParaRPr lang="en-US"/>
           </a:p>
         </p:txBody>
       </p:sp>
@@ -2670,38 +4486,37 @@
           <a:p>
             <a:pPr lvl="0"/>
             <a:r>
-              <a:rPr lang="en-US" smtClean="0"/>
+              <a:rPr lang="en-US"/>
               <a:t>Click to edit Master text styles</a:t>
             </a:r>
           </a:p>
           <a:p>
             <a:pPr lvl="1"/>
             <a:r>
-              <a:rPr lang="en-US" smtClean="0"/>
+              <a:rPr lang="en-US"/>
               <a:t>Second level</a:t>
             </a:r>
           </a:p>
           <a:p>
             <a:pPr lvl="2"/>
             <a:r>
-              <a:rPr lang="en-US" smtClean="0"/>
+              <a:rPr lang="en-US"/>
               <a:t>Third level</a:t>
             </a:r>
           </a:p>
           <a:p>
             <a:pPr lvl="3"/>
             <a:r>
-              <a:rPr lang="en-US" smtClean="0"/>
+              <a:rPr lang="en-US"/>
               <a:t>Fourth level</a:t>
             </a:r>
           </a:p>
           <a:p>
             <a:pPr lvl="4"/>
             <a:r>
-              <a:rPr lang="en-US" smtClean="0"/>
+              <a:rPr lang="en-US"/>
               <a:t>Fifth level</a:t>
             </a:r>
-            <a:endParaRPr lang="en-US"/>
           </a:p>
         </p:txBody>
       </p:sp>
@@ -2740,7 +4555,7 @@
           <a:p>
             <a:fld id="{5BCAD085-E8A6-8845-BD4E-CB4CCA059FC4}" type="datetimeFigureOut">
               <a:rPr lang="en-US" smtClean="0"/>
-              <a:t>1/27/13</a:t>
+              <a:t>9/1/26</a:t>
             </a:fld>
             <a:endParaRPr lang="en-US"/>
           </a:p>
@@ -3099,7 +4914,7 @@
 </file>
 
 <file path=ppt/slides/slide1.xml><?xml version="1.0" encoding="utf-8"?>
-<p:sld xmlns:a="http://schemas.openxmlformats.org/drawingml/2006/main" xmlns:p="http://schemas.openxmlformats.org/presentationml/2006/main" xmlns:r="http://schemas.openxmlformats.org/officeDocument/2006/relationships">
+<p:sld xmlns:a="http://schemas.openxmlformats.org/drawingml/2006/main" xmlns:r="http://schemas.openxmlformats.org/officeDocument/2006/relationships" xmlns:p="http://schemas.openxmlformats.org/presentationml/2006/main">
   <p:cSld>
     <p:spTree>
       <p:nvGrpSpPr>
@@ -3107,7 +4922,14 @@
         <p:cNvGrpSpPr/>
         <p:nvPr/>
       </p:nvGrpSpPr>
-      <p:grpSpPr/>
+      <p:grpSpPr>
+        <a:xfrm>
+          <a:off x="0" y="0"/>
+          <a:ext cx="0" cy="0"/>
+          <a:chOff x="0" y="0"/>
+          <a:chExt cx="0" cy="0"/>
+        </a:xfrm>
+      </p:grpSpPr>
       <p:sp>
         <p:nvSpPr>
           <p:cNvPr id="2" name="TextBox 1"/>
@@ -3117,7 +4939,7 @@
         <p:spPr>
           <a:xfrm>
             <a:off x="731520" y="2103120"/>
-            <a:ext cx="10698480" cy="2743200"/>
+            <a:ext cx="10698480" cy="2215991"/>
           </a:xfrm>
           <a:prstGeom prst="rect">
             <a:avLst/>
@@ -3136,8 +4958,21 @@
                   <a:srgbClr val="1F3A5F"/>
                 </a:solidFill>
               </a:rPr>
-              <a:t>From the Scanner to the Living Room:</a:t>
-            </a:r>
+              <a:t>From Scanner to</a:t>
+            </a:r>
+            <a:r>
+              <a:rPr lang="en-US" sz="3400" b="1">
+                <a:solidFill>
+                  <a:srgbClr val="1F3A5F"/>
+                </a:solidFill>
+              </a:rPr>
+              <a:t> Wearable</a:t>
+            </a:r>
+            <a:endParaRPr sz="3400" b="1">
+              <a:solidFill>
+                <a:srgbClr val="1F3A5F"/>
+              </a:solidFill>
+            </a:endParaRPr>
           </a:p>
           <a:p>
             <a:r>
@@ -3150,14 +4985,79 @@
             </a:r>
           </a:p>
           <a:p>
+            <a:endParaRPr lang="en-US" sz="1600">
+              <a:solidFill>
+                <a:srgbClr val="555555"/>
+              </a:solidFill>
+            </a:endParaRPr>
+          </a:p>
+          <a:p>
+            <a:endParaRPr lang="en-US" sz="1600">
+              <a:solidFill>
+                <a:srgbClr val="555555"/>
+              </a:solidFill>
+            </a:endParaRPr>
+          </a:p>
+          <a:p>
+            <a:r>
+              <a:rPr lang="en-US" sz="1600">
+                <a:solidFill>
+                  <a:srgbClr val="555555"/>
+                </a:solidFill>
+              </a:rPr>
+              <a:t>Clemens Bauer</a:t>
+            </a:r>
             <a:r>
               <a:rPr sz="1600">
                 <a:solidFill>
                   <a:srgbClr val="555555"/>
                 </a:solidFill>
               </a:rPr>
-              <a:t>[Your name] · [Lab/Department] · [Date]</a:t>
-            </a:r>
+              <a:t>· </a:t>
+            </a:r>
+            <a:endParaRPr lang="en-US" sz="1600">
+              <a:solidFill>
+                <a:srgbClr val="555555"/>
+              </a:solidFill>
+            </a:endParaRPr>
+          </a:p>
+          <a:p>
+            <a:r>
+              <a:rPr lang="en-US" sz="1600">
+                <a:solidFill>
+                  <a:srgbClr val="555555"/>
+                </a:solidFill>
+              </a:rPr>
+              <a:t>Epic Lab Center for Precition Psychiatry</a:t>
+            </a:r>
+            <a:r>
+              <a:rPr sz="1600">
+                <a:solidFill>
+                  <a:srgbClr val="555555"/>
+                </a:solidFill>
+              </a:rPr>
+              <a:t>· </a:t>
+            </a:r>
+            <a:endParaRPr lang="en-US" sz="1600">
+              <a:solidFill>
+                <a:srgbClr val="555555"/>
+              </a:solidFill>
+            </a:endParaRPr>
+          </a:p>
+          <a:p>
+            <a:r>
+              <a:rPr lang="en-US" sz="1600">
+                <a:solidFill>
+                  <a:srgbClr val="555555"/>
+                </a:solidFill>
+              </a:rPr>
+              <a:t>09.02.2026</a:t>
+            </a:r>
+            <a:endParaRPr sz="1600">
+              <a:solidFill>
+                <a:srgbClr val="555555"/>
+              </a:solidFill>
+            </a:endParaRPr>
           </a:p>
         </p:txBody>
       </p:sp>
@@ -3170,7 +5070,7 @@
 </file>
 
 <file path=ppt/slides/slide10.xml><?xml version="1.0" encoding="utf-8"?>
-<p:sld xmlns:a="http://schemas.openxmlformats.org/drawingml/2006/main" xmlns:p="http://schemas.openxmlformats.org/presentationml/2006/main" xmlns:r="http://schemas.openxmlformats.org/officeDocument/2006/relationships">
+<p:sld xmlns:a="http://schemas.openxmlformats.org/drawingml/2006/main" xmlns:r="http://schemas.openxmlformats.org/officeDocument/2006/relationships" xmlns:p="http://schemas.openxmlformats.org/presentationml/2006/main">
   <p:cSld>
     <p:spTree>
       <p:nvGrpSpPr>
@@ -3178,7 +5078,14 @@
         <p:cNvGrpSpPr/>
         <p:nvPr/>
       </p:nvGrpSpPr>
-      <p:grpSpPr/>
+      <p:grpSpPr>
+        <a:xfrm>
+          <a:off x="0" y="0"/>
+          <a:ext cx="0" cy="0"/>
+          <a:chOff x="0" y="0"/>
+          <a:chExt cx="0" cy="0"/>
+        </a:xfrm>
+      </p:grpSpPr>
       <p:sp>
         <p:nvSpPr>
           <p:cNvPr id="2" name="TextBox 1"/>
@@ -3302,7 +5209,7 @@
 </file>
 
 <file path=ppt/slides/slide11.xml><?xml version="1.0" encoding="utf-8"?>
-<p:sld xmlns:a="http://schemas.openxmlformats.org/drawingml/2006/main" xmlns:p="http://schemas.openxmlformats.org/presentationml/2006/main" xmlns:r="http://schemas.openxmlformats.org/officeDocument/2006/relationships">
+<p:sld xmlns:a="http://schemas.openxmlformats.org/drawingml/2006/main" xmlns:r="http://schemas.openxmlformats.org/officeDocument/2006/relationships" xmlns:p="http://schemas.openxmlformats.org/presentationml/2006/main">
   <p:cSld>
     <p:spTree>
       <p:nvGrpSpPr>
@@ -3310,7 +5217,14 @@
         <p:cNvGrpSpPr/>
         <p:nvPr/>
       </p:nvGrpSpPr>
-      <p:grpSpPr/>
+      <p:grpSpPr>
+        <a:xfrm>
+          <a:off x="0" y="0"/>
+          <a:ext cx="0" cy="0"/>
+          <a:chOff x="0" y="0"/>
+          <a:chExt cx="0" cy="0"/>
+        </a:xfrm>
+      </p:grpSpPr>
       <p:sp>
         <p:nvSpPr>
           <p:cNvPr id="2" name="TextBox 1"/>
@@ -3421,7 +5335,7 @@
 </file>
 
 <file path=ppt/slides/slide12.xml><?xml version="1.0" encoding="utf-8"?>
-<p:sld xmlns:a="http://schemas.openxmlformats.org/drawingml/2006/main" xmlns:p="http://schemas.openxmlformats.org/presentationml/2006/main" xmlns:r="http://schemas.openxmlformats.org/officeDocument/2006/relationships">
+<p:sld xmlns:a="http://schemas.openxmlformats.org/drawingml/2006/main" xmlns:r="http://schemas.openxmlformats.org/officeDocument/2006/relationships" xmlns:p="http://schemas.openxmlformats.org/presentationml/2006/main">
   <p:cSld>
     <p:spTree>
       <p:nvGrpSpPr>
@@ -3429,7 +5343,14 @@
         <p:cNvGrpSpPr/>
         <p:nvPr/>
       </p:nvGrpSpPr>
-      <p:grpSpPr/>
+      <p:grpSpPr>
+        <a:xfrm>
+          <a:off x="0" y="0"/>
+          <a:ext cx="0" cy="0"/>
+          <a:chOff x="0" y="0"/>
+          <a:chExt cx="0" cy="0"/>
+        </a:xfrm>
+      </p:grpSpPr>
       <p:sp>
         <p:nvSpPr>
           <p:cNvPr id="2" name="TextBox 1"/>
@@ -3540,7 +5461,7 @@
 </file>
 
 <file path=ppt/slides/slide13.xml><?xml version="1.0" encoding="utf-8"?>
-<p:sld xmlns:a="http://schemas.openxmlformats.org/drawingml/2006/main" xmlns:p="http://schemas.openxmlformats.org/presentationml/2006/main" xmlns:r="http://schemas.openxmlformats.org/officeDocument/2006/relationships">
+<p:sld xmlns:a="http://schemas.openxmlformats.org/drawingml/2006/main" xmlns:r="http://schemas.openxmlformats.org/officeDocument/2006/relationships" xmlns:p="http://schemas.openxmlformats.org/presentationml/2006/main">
   <p:cSld>
     <p:spTree>
       <p:nvGrpSpPr>
@@ -3548,7 +5469,14 @@
         <p:cNvGrpSpPr/>
         <p:nvPr/>
       </p:nvGrpSpPr>
-      <p:grpSpPr/>
+      <p:grpSpPr>
+        <a:xfrm>
+          <a:off x="0" y="0"/>
+          <a:ext cx="0" cy="0"/>
+          <a:chOff x="0" y="0"/>
+          <a:chExt cx="0" cy="0"/>
+        </a:xfrm>
+      </p:grpSpPr>
       <p:sp>
         <p:nvSpPr>
           <p:cNvPr id="2" name="TextBox 1"/>
@@ -3680,7 +5608,7 @@
 </file>
 
 <file path=ppt/slides/slide14.xml><?xml version="1.0" encoding="utf-8"?>
-<p:sld xmlns:a="http://schemas.openxmlformats.org/drawingml/2006/main" xmlns:p="http://schemas.openxmlformats.org/presentationml/2006/main" xmlns:r="http://schemas.openxmlformats.org/officeDocument/2006/relationships">
+<p:sld xmlns:a="http://schemas.openxmlformats.org/drawingml/2006/main" xmlns:r="http://schemas.openxmlformats.org/officeDocument/2006/relationships" xmlns:p="http://schemas.openxmlformats.org/presentationml/2006/main">
   <p:cSld>
     <p:spTree>
       <p:nvGrpSpPr>
@@ -3688,7 +5616,14 @@
         <p:cNvGrpSpPr/>
         <p:nvPr/>
       </p:nvGrpSpPr>
-      <p:grpSpPr/>
+      <p:grpSpPr>
+        <a:xfrm>
+          <a:off x="0" y="0"/>
+          <a:ext cx="0" cy="0"/>
+          <a:chOff x="0" y="0"/>
+          <a:chExt cx="0" cy="0"/>
+        </a:xfrm>
+      </p:grpSpPr>
       <p:sp>
         <p:nvSpPr>
           <p:cNvPr id="2" name="TextBox 1"/>
@@ -3801,7 +5736,7 @@
 </file>
 
 <file path=ppt/slides/slide15.xml><?xml version="1.0" encoding="utf-8"?>
-<p:sld xmlns:a="http://schemas.openxmlformats.org/drawingml/2006/main" xmlns:p="http://schemas.openxmlformats.org/presentationml/2006/main" xmlns:r="http://schemas.openxmlformats.org/officeDocument/2006/relationships">
+<p:sld xmlns:a="http://schemas.openxmlformats.org/drawingml/2006/main" xmlns:r="http://schemas.openxmlformats.org/officeDocument/2006/relationships" xmlns:p="http://schemas.openxmlformats.org/presentationml/2006/main">
   <p:cSld>
     <p:spTree>
       <p:nvGrpSpPr>
@@ -3809,7 +5744,14 @@
         <p:cNvGrpSpPr/>
         <p:nvPr/>
       </p:nvGrpSpPr>
-      <p:grpSpPr/>
+      <p:grpSpPr>
+        <a:xfrm>
+          <a:off x="0" y="0"/>
+          <a:ext cx="0" cy="0"/>
+          <a:chOff x="0" y="0"/>
+          <a:chExt cx="0" cy="0"/>
+        </a:xfrm>
+      </p:grpSpPr>
       <p:sp>
         <p:nvSpPr>
           <p:cNvPr id="2" name="TextBox 1"/>
@@ -3974,7 +5916,7 @@
 </file>
 
 <file path=ppt/slides/slide16.xml><?xml version="1.0" encoding="utf-8"?>
-<p:sld xmlns:a="http://schemas.openxmlformats.org/drawingml/2006/main" xmlns:p="http://schemas.openxmlformats.org/presentationml/2006/main" xmlns:r="http://schemas.openxmlformats.org/officeDocument/2006/relationships">
+<p:sld xmlns:a="http://schemas.openxmlformats.org/drawingml/2006/main" xmlns:r="http://schemas.openxmlformats.org/officeDocument/2006/relationships" xmlns:p="http://schemas.openxmlformats.org/presentationml/2006/main">
   <p:cSld>
     <p:spTree>
       <p:nvGrpSpPr>
@@ -3982,7 +5924,14 @@
         <p:cNvGrpSpPr/>
         <p:nvPr/>
       </p:nvGrpSpPr>
-      <p:grpSpPr/>
+      <p:grpSpPr>
+        <a:xfrm>
+          <a:off x="0" y="0"/>
+          <a:ext cx="0" cy="0"/>
+          <a:chOff x="0" y="0"/>
+          <a:chExt cx="0" cy="0"/>
+        </a:xfrm>
+      </p:grpSpPr>
       <p:sp>
         <p:nvSpPr>
           <p:cNvPr id="2" name="TextBox 1"/>
@@ -4107,7 +6056,7 @@
 </file>
 
 <file path=ppt/slides/slide17.xml><?xml version="1.0" encoding="utf-8"?>
-<p:sld xmlns:a="http://schemas.openxmlformats.org/drawingml/2006/main" xmlns:p="http://schemas.openxmlformats.org/presentationml/2006/main" xmlns:r="http://schemas.openxmlformats.org/officeDocument/2006/relationships">
+<p:sld xmlns:a="http://schemas.openxmlformats.org/drawingml/2006/main" xmlns:r="http://schemas.openxmlformats.org/officeDocument/2006/relationships" xmlns:p="http://schemas.openxmlformats.org/presentationml/2006/main">
   <p:cSld>
     <p:spTree>
       <p:nvGrpSpPr>
@@ -4115,7 +6064,14 @@
         <p:cNvGrpSpPr/>
         <p:nvPr/>
       </p:nvGrpSpPr>
-      <p:grpSpPr/>
+      <p:grpSpPr>
+        <a:xfrm>
+          <a:off x="0" y="0"/>
+          <a:ext cx="0" cy="0"/>
+          <a:chOff x="0" y="0"/>
+          <a:chExt cx="0" cy="0"/>
+        </a:xfrm>
+      </p:grpSpPr>
       <p:sp>
         <p:nvSpPr>
           <p:cNvPr id="2" name="TextBox 1"/>
@@ -4218,7 +6174,7 @@
 </file>
 
 <file path=ppt/slides/slide18.xml><?xml version="1.0" encoding="utf-8"?>
-<p:sld xmlns:a="http://schemas.openxmlformats.org/drawingml/2006/main" xmlns:p="http://schemas.openxmlformats.org/presentationml/2006/main" xmlns:r="http://schemas.openxmlformats.org/officeDocument/2006/relationships">
+<p:sld xmlns:a="http://schemas.openxmlformats.org/drawingml/2006/main" xmlns:r="http://schemas.openxmlformats.org/officeDocument/2006/relationships" xmlns:p="http://schemas.openxmlformats.org/presentationml/2006/main">
   <p:cSld>
     <p:spTree>
       <p:nvGrpSpPr>
@@ -4226,7 +6182,14 @@
         <p:cNvGrpSpPr/>
         <p:nvPr/>
       </p:nvGrpSpPr>
-      <p:grpSpPr/>
+      <p:grpSpPr>
+        <a:xfrm>
+          <a:off x="0" y="0"/>
+          <a:ext cx="0" cy="0"/>
+          <a:chOff x="0" y="0"/>
+          <a:chExt cx="0" cy="0"/>
+        </a:xfrm>
+      </p:grpSpPr>
       <p:sp>
         <p:nvSpPr>
           <p:cNvPr id="2" name="TextBox 1"/>
@@ -4340,7 +6303,7 @@
 </file>
 
 <file path=ppt/slides/slide19.xml><?xml version="1.0" encoding="utf-8"?>
-<p:sld xmlns:a="http://schemas.openxmlformats.org/drawingml/2006/main" xmlns:p="http://schemas.openxmlformats.org/presentationml/2006/main" xmlns:r="http://schemas.openxmlformats.org/officeDocument/2006/relationships">
+<p:sld xmlns:a="http://schemas.openxmlformats.org/drawingml/2006/main" xmlns:r="http://schemas.openxmlformats.org/officeDocument/2006/relationships" xmlns:p="http://schemas.openxmlformats.org/presentationml/2006/main">
   <p:cSld>
     <p:spTree>
       <p:nvGrpSpPr>
@@ -4348,7 +6311,14 @@
         <p:cNvGrpSpPr/>
         <p:nvPr/>
       </p:nvGrpSpPr>
-      <p:grpSpPr/>
+      <p:grpSpPr>
+        <a:xfrm>
+          <a:off x="0" y="0"/>
+          <a:ext cx="0" cy="0"/>
+          <a:chOff x="0" y="0"/>
+          <a:chExt cx="0" cy="0"/>
+        </a:xfrm>
+      </p:grpSpPr>
       <p:sp>
         <p:nvSpPr>
           <p:cNvPr id="2" name="TextBox 1"/>
@@ -4451,7 +6421,7 @@
 </file>
 
 <file path=ppt/slides/slide2.xml><?xml version="1.0" encoding="utf-8"?>
-<p:sld xmlns:a="http://schemas.openxmlformats.org/drawingml/2006/main" xmlns:p="http://schemas.openxmlformats.org/presentationml/2006/main" xmlns:r="http://schemas.openxmlformats.org/officeDocument/2006/relationships">
+<p:sld xmlns:a="http://schemas.openxmlformats.org/drawingml/2006/main" xmlns:r="http://schemas.openxmlformats.org/officeDocument/2006/relationships" xmlns:p="http://schemas.openxmlformats.org/presentationml/2006/main">
   <p:cSld>
     <p:spTree>
       <p:nvGrpSpPr>
@@ -4459,7 +6429,14 @@
         <p:cNvGrpSpPr/>
         <p:nvPr/>
       </p:nvGrpSpPr>
-      <p:grpSpPr/>
+      <p:grpSpPr>
+        <a:xfrm>
+          <a:off x="0" y="0"/>
+          <a:ext cx="0" cy="0"/>
+          <a:chOff x="0" y="0"/>
+          <a:chExt cx="0" cy="0"/>
+        </a:xfrm>
+      </p:grpSpPr>
       <p:sp>
         <p:nvSpPr>
           <p:cNvPr id="2" name="TextBox 1"/>
@@ -4577,7 +6554,7 @@
 </file>
 
 <file path=ppt/slides/slide20.xml><?xml version="1.0" encoding="utf-8"?>
-<p:sld xmlns:a="http://schemas.openxmlformats.org/drawingml/2006/main" xmlns:p="http://schemas.openxmlformats.org/presentationml/2006/main" xmlns:r="http://schemas.openxmlformats.org/officeDocument/2006/relationships">
+<p:sld xmlns:a="http://schemas.openxmlformats.org/drawingml/2006/main" xmlns:r="http://schemas.openxmlformats.org/officeDocument/2006/relationships" xmlns:p="http://schemas.openxmlformats.org/presentationml/2006/main">
   <p:cSld>
     <p:spTree>
       <p:nvGrpSpPr>
@@ -4585,7 +6562,14 @@
         <p:cNvGrpSpPr/>
         <p:nvPr/>
       </p:nvGrpSpPr>
-      <p:grpSpPr/>
+      <p:grpSpPr>
+        <a:xfrm>
+          <a:off x="0" y="0"/>
+          <a:ext cx="0" cy="0"/>
+          <a:chOff x="0" y="0"/>
+          <a:chExt cx="0" cy="0"/>
+        </a:xfrm>
+      </p:grpSpPr>
       <p:sp>
         <p:nvSpPr>
           <p:cNvPr id="2" name="TextBox 1"/>
@@ -4688,7 +6672,7 @@
 </file>
 
 <file path=ppt/slides/slide21.xml><?xml version="1.0" encoding="utf-8"?>
-<p:sld xmlns:a="http://schemas.openxmlformats.org/drawingml/2006/main" xmlns:p="http://schemas.openxmlformats.org/presentationml/2006/main" xmlns:r="http://schemas.openxmlformats.org/officeDocument/2006/relationships">
+<p:sld xmlns:a="http://schemas.openxmlformats.org/drawingml/2006/main" xmlns:r="http://schemas.openxmlformats.org/officeDocument/2006/relationships" xmlns:p="http://schemas.openxmlformats.org/presentationml/2006/main">
   <p:cSld>
     <p:spTree>
       <p:nvGrpSpPr>
@@ -4696,7 +6680,14 @@
         <p:cNvGrpSpPr/>
         <p:nvPr/>
       </p:nvGrpSpPr>
-      <p:grpSpPr/>
+      <p:grpSpPr>
+        <a:xfrm>
+          <a:off x="0" y="0"/>
+          <a:ext cx="0" cy="0"/>
+          <a:chOff x="0" y="0"/>
+          <a:chExt cx="0" cy="0"/>
+        </a:xfrm>
+      </p:grpSpPr>
       <p:sp>
         <p:nvSpPr>
           <p:cNvPr id="2" name="TextBox 1"/>
@@ -4820,7 +6811,7 @@
 </file>
 
 <file path=ppt/slides/slide3.xml><?xml version="1.0" encoding="utf-8"?>
-<p:sld xmlns:a="http://schemas.openxmlformats.org/drawingml/2006/main" xmlns:p="http://schemas.openxmlformats.org/presentationml/2006/main" xmlns:r="http://schemas.openxmlformats.org/officeDocument/2006/relationships">
+<p:sld xmlns:a="http://schemas.openxmlformats.org/drawingml/2006/main" xmlns:r="http://schemas.openxmlformats.org/officeDocument/2006/relationships" xmlns:p="http://schemas.openxmlformats.org/presentationml/2006/main">
   <p:cSld>
     <p:spTree>
       <p:nvGrpSpPr>
@@ -4828,7 +6819,14 @@
         <p:cNvGrpSpPr/>
         <p:nvPr/>
       </p:nvGrpSpPr>
-      <p:grpSpPr/>
+      <p:grpSpPr>
+        <a:xfrm>
+          <a:off x="0" y="0"/>
+          <a:ext cx="0" cy="0"/>
+          <a:chOff x="0" y="0"/>
+          <a:chExt cx="0" cy="0"/>
+        </a:xfrm>
+      </p:grpSpPr>
       <p:sp>
         <p:nvSpPr>
           <p:cNvPr id="2" name="TextBox 1"/>
@@ -4931,7 +6929,7 @@
 </file>
 
 <file path=ppt/slides/slide4.xml><?xml version="1.0" encoding="utf-8"?>
-<p:sld xmlns:a="http://schemas.openxmlformats.org/drawingml/2006/main" xmlns:p="http://schemas.openxmlformats.org/presentationml/2006/main" xmlns:r="http://schemas.openxmlformats.org/officeDocument/2006/relationships">
+<p:sld xmlns:a="http://schemas.openxmlformats.org/drawingml/2006/main" xmlns:r="http://schemas.openxmlformats.org/officeDocument/2006/relationships" xmlns:p="http://schemas.openxmlformats.org/presentationml/2006/main">
   <p:cSld>
     <p:spTree>
       <p:nvGrpSpPr>
@@ -4939,7 +6937,14 @@
         <p:cNvGrpSpPr/>
         <p:nvPr/>
       </p:nvGrpSpPr>
-      <p:grpSpPr/>
+      <p:grpSpPr>
+        <a:xfrm>
+          <a:off x="0" y="0"/>
+          <a:ext cx="0" cy="0"/>
+          <a:chOff x="0" y="0"/>
+          <a:chExt cx="0" cy="0"/>
+        </a:xfrm>
+      </p:grpSpPr>
       <p:sp>
         <p:nvSpPr>
           <p:cNvPr id="2" name="TextBox 1"/>
@@ -5053,7 +7058,7 @@
 </file>
 
 <file path=ppt/slides/slide5.xml><?xml version="1.0" encoding="utf-8"?>
-<p:sld xmlns:a="http://schemas.openxmlformats.org/drawingml/2006/main" xmlns:p="http://schemas.openxmlformats.org/presentationml/2006/main" xmlns:r="http://schemas.openxmlformats.org/officeDocument/2006/relationships">
+<p:sld xmlns:a="http://schemas.openxmlformats.org/drawingml/2006/main" xmlns:r="http://schemas.openxmlformats.org/officeDocument/2006/relationships" xmlns:p="http://schemas.openxmlformats.org/presentationml/2006/main">
   <p:cSld>
     <p:spTree>
       <p:nvGrpSpPr>
@@ -5061,7 +7066,14 @@
         <p:cNvGrpSpPr/>
         <p:nvPr/>
       </p:nvGrpSpPr>
-      <p:grpSpPr/>
+      <p:grpSpPr>
+        <a:xfrm>
+          <a:off x="0" y="0"/>
+          <a:ext cx="0" cy="0"/>
+          <a:chOff x="0" y="0"/>
+          <a:chExt cx="0" cy="0"/>
+        </a:xfrm>
+      </p:grpSpPr>
       <p:sp>
         <p:nvSpPr>
           <p:cNvPr id="2" name="TextBox 1"/>
@@ -5179,7 +7191,7 @@
 </file>
 
 <file path=ppt/slides/slide6.xml><?xml version="1.0" encoding="utf-8"?>
-<p:sld xmlns:a="http://schemas.openxmlformats.org/drawingml/2006/main" xmlns:p="http://schemas.openxmlformats.org/presentationml/2006/main" xmlns:r="http://schemas.openxmlformats.org/officeDocument/2006/relationships">
+<p:sld xmlns:a="http://schemas.openxmlformats.org/drawingml/2006/main" xmlns:r="http://schemas.openxmlformats.org/officeDocument/2006/relationships" xmlns:p="http://schemas.openxmlformats.org/presentationml/2006/main">
   <p:cSld>
     <p:spTree>
       <p:nvGrpSpPr>
@@ -5187,7 +7199,14 @@
         <p:cNvGrpSpPr/>
         <p:nvPr/>
       </p:nvGrpSpPr>
-      <p:grpSpPr/>
+      <p:grpSpPr>
+        <a:xfrm>
+          <a:off x="0" y="0"/>
+          <a:ext cx="0" cy="0"/>
+          <a:chOff x="0" y="0"/>
+          <a:chExt cx="0" cy="0"/>
+        </a:xfrm>
+      </p:grpSpPr>
       <p:sp>
         <p:nvSpPr>
           <p:cNvPr id="2" name="TextBox 1"/>
@@ -5286,7 +7305,7 @@
 </file>
 
 <file path=ppt/slides/slide7.xml><?xml version="1.0" encoding="utf-8"?>
-<p:sld xmlns:a="http://schemas.openxmlformats.org/drawingml/2006/main" xmlns:p="http://schemas.openxmlformats.org/presentationml/2006/main" xmlns:r="http://schemas.openxmlformats.org/officeDocument/2006/relationships">
+<p:sld xmlns:a="http://schemas.openxmlformats.org/drawingml/2006/main" xmlns:r="http://schemas.openxmlformats.org/officeDocument/2006/relationships" xmlns:p="http://schemas.openxmlformats.org/presentationml/2006/main">
   <p:cSld>
     <p:spTree>
       <p:nvGrpSpPr>
@@ -5294,7 +7313,14 @@
         <p:cNvGrpSpPr/>
         <p:nvPr/>
       </p:nvGrpSpPr>
-      <p:grpSpPr/>
+      <p:grpSpPr>
+        <a:xfrm>
+          <a:off x="0" y="0"/>
+          <a:ext cx="0" cy="0"/>
+          <a:chOff x="0" y="0"/>
+          <a:chExt cx="0" cy="0"/>
+        </a:xfrm>
+      </p:grpSpPr>
       <p:sp>
         <p:nvSpPr>
           <p:cNvPr id="2" name="TextBox 1"/>
@@ -5433,7 +7459,7 @@
 </file>
 
 <file path=ppt/slides/slide8.xml><?xml version="1.0" encoding="utf-8"?>
-<p:sld xmlns:a="http://schemas.openxmlformats.org/drawingml/2006/main" xmlns:p="http://schemas.openxmlformats.org/presentationml/2006/main" xmlns:r="http://schemas.openxmlformats.org/officeDocument/2006/relationships">
+<p:sld xmlns:a="http://schemas.openxmlformats.org/drawingml/2006/main" xmlns:r="http://schemas.openxmlformats.org/officeDocument/2006/relationships" xmlns:p="http://schemas.openxmlformats.org/presentationml/2006/main">
   <p:cSld>
     <p:spTree>
       <p:nvGrpSpPr>
@@ -5441,7 +7467,14 @@
         <p:cNvGrpSpPr/>
         <p:nvPr/>
       </p:nvGrpSpPr>
-      <p:grpSpPr/>
+      <p:grpSpPr>
+        <a:xfrm>
+          <a:off x="0" y="0"/>
+          <a:ext cx="0" cy="0"/>
+          <a:chOff x="0" y="0"/>
+          <a:chExt cx="0" cy="0"/>
+        </a:xfrm>
+      </p:grpSpPr>
       <p:sp>
         <p:nvSpPr>
           <p:cNvPr id="2" name="TextBox 1"/>
@@ -5559,7 +7592,7 @@
 </file>
 
 <file path=ppt/slides/slide9.xml><?xml version="1.0" encoding="utf-8"?>
-<p:sld xmlns:a="http://schemas.openxmlformats.org/drawingml/2006/main" xmlns:p="http://schemas.openxmlformats.org/presentationml/2006/main" xmlns:r="http://schemas.openxmlformats.org/officeDocument/2006/relationships">
+<p:sld xmlns:a="http://schemas.openxmlformats.org/drawingml/2006/main" xmlns:r="http://schemas.openxmlformats.org/officeDocument/2006/relationships" xmlns:p="http://schemas.openxmlformats.org/presentationml/2006/main">
   <p:cSld>
     <p:spTree>
       <p:nvGrpSpPr>
@@ -5567,7 +7600,14 @@
         <p:cNvGrpSpPr/>
         <p:nvPr/>
       </p:nvGrpSpPr>
-      <p:grpSpPr/>
+      <p:grpSpPr>
+        <a:xfrm>
+          <a:off x="0" y="0"/>
+          <a:ext cx="0" cy="0"/>
+          <a:chOff x="0" y="0"/>
+          <a:chExt cx="0" cy="0"/>
+        </a:xfrm>
+      </p:grpSpPr>
       <p:sp>
         <p:nvSpPr>
           <p:cNvPr id="2" name="TextBox 1"/>
@@ -6019,4 +8059,330 @@
   </a:objectDefaults>
   <a:extraClrSchemeLst/>
 </a:theme>
+</file>
+
+<file path=ppt/theme/theme2.xml><?xml version="1.0" encoding="utf-8"?>
+<a:theme xmlns:a="http://schemas.openxmlformats.org/drawingml/2006/main" name="Office Theme">
+  <a:themeElements>
+    <a:clrScheme name="Office">
+      <a:dk1>
+        <a:sysClr val="windowText" lastClr="000000"/>
+      </a:dk1>
+      <a:lt1>
+        <a:sysClr val="window" lastClr="FFFFFF"/>
+      </a:lt1>
+      <a:dk2>
+        <a:srgbClr val="1F497D"/>
+      </a:dk2>
+      <a:lt2>
+        <a:srgbClr val="EEECE1"/>
+      </a:lt2>
+      <a:accent1>
+        <a:srgbClr val="4F81BD"/>
+      </a:accent1>
+      <a:accent2>
+        <a:srgbClr val="C0504D"/>
+      </a:accent2>
+      <a:accent3>
+        <a:srgbClr val="9BBB59"/>
+      </a:accent3>
+      <a:accent4>
+        <a:srgbClr val="8064A2"/>
+      </a:accent4>
+      <a:accent5>
+        <a:srgbClr val="4BACC6"/>
+      </a:accent5>
+      <a:accent6>
+        <a:srgbClr val="F79646"/>
+      </a:accent6>
+      <a:hlink>
+        <a:srgbClr val="0000FF"/>
+      </a:hlink>
+      <a:folHlink>
+        <a:srgbClr val="800080"/>
+      </a:folHlink>
+    </a:clrScheme>
+    <a:fontScheme name="Office">
+      <a:majorFont>
+        <a:latin typeface="Calibri"/>
+        <a:ea typeface=""/>
+        <a:cs typeface=""/>
+        <a:font script="Jpan" typeface="ＭＳ Ｐゴシック"/>
+        <a:font script="Hang" typeface="맑은 고딕"/>
+        <a:font script="Hans" typeface="宋体"/>
+        <a:font script="Hant" typeface="新細明體"/>
+        <a:font script="Arab" typeface="Times New Roman"/>
+        <a:font script="Hebr" typeface="Times New Roman"/>
+        <a:font script="Thai" typeface="Angsana New"/>
+        <a:font script="Ethi" typeface="Nyala"/>
+        <a:font script="Beng" typeface="Vrinda"/>
+        <a:font script="Gujr" typeface="Shruti"/>
+        <a:font script="Khmr" typeface="MoolBoran"/>
+        <a:font script="Knda" typeface="Tunga"/>
+        <a:font script="Guru" typeface="Raavi"/>
+        <a:font script="Cans" typeface="Euphemia"/>
+        <a:font script="Cher" typeface="Plantagenet Cherokee"/>
+        <a:font script="Yiii" typeface="Microsoft Yi Baiti"/>
+        <a:font script="Tibt" typeface="Microsoft Himalaya"/>
+        <a:font script="Thaa" typeface="MV Boli"/>
+        <a:font script="Deva" typeface="Mangal"/>
+        <a:font script="Telu" typeface="Gautami"/>
+        <a:font script="Taml" typeface="Latha"/>
+        <a:font script="Syrc" typeface="Estrangelo Edessa"/>
+        <a:font script="Orya" typeface="Kalinga"/>
+        <a:font script="Mlym" typeface="Kartika"/>
+        <a:font script="Laoo" typeface="DokChampa"/>
+        <a:font script="Sinh" typeface="Iskoola Pota"/>
+        <a:font script="Mong" typeface="Mongolian Baiti"/>
+        <a:font script="Viet" typeface="Times New Roman"/>
+        <a:font script="Uigh" typeface="Microsoft Uighur"/>
+        <a:font script="Geor" typeface="Sylfaen"/>
+      </a:majorFont>
+      <a:minorFont>
+        <a:latin typeface="Calibri"/>
+        <a:ea typeface=""/>
+        <a:cs typeface=""/>
+        <a:font script="Jpan" typeface="ＭＳ Ｐゴシック"/>
+        <a:font script="Hang" typeface="맑은 고딕"/>
+        <a:font script="Hans" typeface="宋体"/>
+        <a:font script="Hant" typeface="新細明體"/>
+        <a:font script="Arab" typeface="Arial"/>
+        <a:font script="Hebr" typeface="Arial"/>
+        <a:font script="Thai" typeface="Cordia New"/>
+        <a:font script="Ethi" typeface="Nyala"/>
+        <a:font script="Beng" typeface="Vrinda"/>
+        <a:font script="Gujr" typeface="Shruti"/>
+        <a:font script="Khmr" typeface="DaunPenh"/>
+        <a:font script="Knda" typeface="Tunga"/>
+        <a:font script="Guru" typeface="Raavi"/>
+        <a:font script="Cans" typeface="Euphemia"/>
+        <a:font script="Cher" typeface="Plantagenet Cherokee"/>
+        <a:font script="Yiii" typeface="Microsoft Yi Baiti"/>
+        <a:font script="Tibt" typeface="Microsoft Himalaya"/>
+        <a:font script="Thaa" typeface="MV Boli"/>
+        <a:font script="Deva" typeface="Mangal"/>
+        <a:font script="Telu" typeface="Gautami"/>
+        <a:font script="Taml" typeface="Latha"/>
+        <a:font script="Syrc" typeface="Estrangelo Edessa"/>
+        <a:font script="Orya" typeface="Kalinga"/>
+        <a:font script="Mlym" typeface="Kartika"/>
+        <a:font script="Laoo" typeface="DokChampa"/>
+        <a:font script="Sinh" typeface="Iskoola Pota"/>
+        <a:font script="Mong" typeface="Mongolian Baiti"/>
+        <a:font script="Viet" typeface="Arial"/>
+        <a:font script="Uigh" typeface="Microsoft Uighur"/>
+        <a:font script="Geor" typeface="Sylfaen"/>
+      </a:minorFont>
+    </a:fontScheme>
+    <a:fmtScheme name="Office">
+      <a:fillStyleLst>
+        <a:solidFill>
+          <a:schemeClr val="phClr"/>
+        </a:solidFill>
+        <a:gradFill rotWithShape="1">
+          <a:gsLst>
+            <a:gs pos="0">
+              <a:schemeClr val="phClr">
+                <a:tint val="50000"/>
+                <a:satMod val="300000"/>
+              </a:schemeClr>
+            </a:gs>
+            <a:gs pos="35000">
+              <a:schemeClr val="phClr">
+                <a:tint val="37000"/>
+                <a:satMod val="300000"/>
+              </a:schemeClr>
+            </a:gs>
+            <a:gs pos="100000">
+              <a:schemeClr val="phClr">
+                <a:tint val="15000"/>
+                <a:satMod val="350000"/>
+              </a:schemeClr>
+            </a:gs>
+          </a:gsLst>
+          <a:lin ang="16200000" scaled="1"/>
+        </a:gradFill>
+        <a:gradFill rotWithShape="1">
+          <a:gsLst>
+            <a:gs pos="0">
+              <a:schemeClr val="phClr">
+                <a:tint val="100000"/>
+                <a:shade val="100000"/>
+                <a:satMod val="130000"/>
+              </a:schemeClr>
+            </a:gs>
+            <a:gs pos="100000">
+              <a:schemeClr val="phClr">
+                <a:tint val="50000"/>
+                <a:shade val="100000"/>
+                <a:satMod val="350000"/>
+              </a:schemeClr>
+            </a:gs>
+          </a:gsLst>
+          <a:lin ang="16200000" scaled="0"/>
+        </a:gradFill>
+      </a:fillStyleLst>
+      <a:lnStyleLst>
+        <a:ln w="9525" cap="flat" cmpd="sng" algn="ctr">
+          <a:solidFill>
+            <a:schemeClr val="phClr">
+              <a:shade val="95000"/>
+              <a:satMod val="105000"/>
+            </a:schemeClr>
+          </a:solidFill>
+          <a:prstDash val="solid"/>
+        </a:ln>
+        <a:ln w="25400" cap="flat" cmpd="sng" algn="ctr">
+          <a:solidFill>
+            <a:schemeClr val="phClr"/>
+          </a:solidFill>
+          <a:prstDash val="solid"/>
+        </a:ln>
+        <a:ln w="38100" cap="flat" cmpd="sng" algn="ctr">
+          <a:solidFill>
+            <a:schemeClr val="phClr"/>
+          </a:solidFill>
+          <a:prstDash val="solid"/>
+        </a:ln>
+      </a:lnStyleLst>
+      <a:effectStyleLst>
+        <a:effectStyle>
+          <a:effectLst>
+            <a:outerShdw blurRad="40000" dist="20000" dir="5400000" rotWithShape="0">
+              <a:srgbClr val="000000">
+                <a:alpha val="38000"/>
+              </a:srgbClr>
+            </a:outerShdw>
+          </a:effectLst>
+        </a:effectStyle>
+        <a:effectStyle>
+          <a:effectLst>
+            <a:outerShdw blurRad="40000" dist="23000" dir="5400000" rotWithShape="0">
+              <a:srgbClr val="000000">
+                <a:alpha val="35000"/>
+              </a:srgbClr>
+            </a:outerShdw>
+          </a:effectLst>
+        </a:effectStyle>
+        <a:effectStyle>
+          <a:effectLst>
+            <a:outerShdw blurRad="40000" dist="23000" dir="5400000" rotWithShape="0">
+              <a:srgbClr val="000000">
+                <a:alpha val="35000"/>
+              </a:srgbClr>
+            </a:outerShdw>
+          </a:effectLst>
+          <a:scene3d>
+            <a:camera prst="orthographicFront">
+              <a:rot lat="0" lon="0" rev="0"/>
+            </a:camera>
+            <a:lightRig rig="threePt" dir="t">
+              <a:rot lat="0" lon="0" rev="1200000"/>
+            </a:lightRig>
+          </a:scene3d>
+          <a:sp3d>
+            <a:bevelT w="63500" h="25400"/>
+          </a:sp3d>
+        </a:effectStyle>
+      </a:effectStyleLst>
+      <a:bgFillStyleLst>
+        <a:solidFill>
+          <a:schemeClr val="phClr"/>
+        </a:solidFill>
+        <a:gradFill rotWithShape="1">
+          <a:gsLst>
+            <a:gs pos="0">
+              <a:schemeClr val="phClr">
+                <a:tint val="40000"/>
+                <a:satMod val="350000"/>
+              </a:schemeClr>
+            </a:gs>
+            <a:gs pos="40000">
+              <a:schemeClr val="phClr">
+                <a:tint val="45000"/>
+                <a:shade val="99000"/>
+                <a:satMod val="350000"/>
+              </a:schemeClr>
+            </a:gs>
+            <a:gs pos="100000">
+              <a:schemeClr val="phClr">
+                <a:shade val="20000"/>
+                <a:satMod val="255000"/>
+              </a:schemeClr>
+            </a:gs>
+          </a:gsLst>
+          <a:path path="circle">
+            <a:fillToRect l="50000" t="-80000" r="50000" b="180000"/>
+          </a:path>
+        </a:gradFill>
+        <a:gradFill rotWithShape="1">
+          <a:gsLst>
+            <a:gs pos="0">
+              <a:schemeClr val="phClr">
+                <a:tint val="80000"/>
+                <a:satMod val="300000"/>
+              </a:schemeClr>
+            </a:gs>
+            <a:gs pos="100000">
+              <a:schemeClr val="phClr">
+                <a:shade val="30000"/>
+                <a:satMod val="200000"/>
+              </a:schemeClr>
+            </a:gs>
+          </a:gsLst>
+          <a:path path="circle">
+            <a:fillToRect l="50000" t="50000" r="50000" b="50000"/>
+          </a:path>
+        </a:gradFill>
+      </a:bgFillStyleLst>
+    </a:fmtScheme>
+  </a:themeElements>
+  <a:objectDefaults>
+    <a:spDef>
+      <a:spPr/>
+      <a:bodyPr/>
+      <a:lstStyle/>
+      <a:style>
+        <a:lnRef idx="1">
+          <a:schemeClr val="accent1"/>
+        </a:lnRef>
+        <a:fillRef idx="3">
+          <a:schemeClr val="accent1"/>
+        </a:fillRef>
+        <a:effectRef idx="2">
+          <a:schemeClr val="accent1"/>
+        </a:effectRef>
+        <a:fontRef idx="minor">
+          <a:schemeClr val="lt1"/>
+        </a:fontRef>
+      </a:style>
+    </a:spDef>
+    <a:lnDef>
+      <a:spPr/>
+      <a:bodyPr/>
+      <a:lstStyle/>
+      <a:style>
+        <a:lnRef idx="2">
+          <a:schemeClr val="accent1"/>
+        </a:lnRef>
+        <a:fillRef idx="0">
+          <a:schemeClr val="accent1"/>
+        </a:fillRef>
+        <a:effectRef idx="1">
+          <a:schemeClr val="accent1"/>
+        </a:effectRef>
+        <a:fontRef idx="minor">
+          <a:schemeClr val="tx1"/>
+        </a:fontRef>
+      </a:style>
+    </a:lnDef>
+  </a:objectDefaults>
+  <a:extraClrSchemeLst/>
+</a:theme>
+</file>
+
+<file path=docMetadata/LabelInfo.xml><?xml version="1.0" encoding="utf-8"?>
+<clbl:labelList xmlns:clbl="http://schemas.microsoft.com/office/2020/mipLabelMetadata">
+  <clbl:label id="{7893ce20-a697-4fd6-a4da-14011f6a471d}" enabled="1" method="Standard" siteId="{a8eec281-aaa3-4dae-ac9b-9a398b9215e7}" contentBits="0" removed="0"/>
+</clbl:labelList>
 </file>
</xml_diff>